<commit_message>
Feat: Story 5.6, recette du Rapport sur données complètes
- Recette lente sur le Journal complet (graine 42, Palier 1) : A et B rouges,
  C orange, une slide chacune, Prévisions A/B et Risque C, 9 onglets.
- Scénarios dédiés : « ↗ aggravation » sur la Carte météo et « aucun Brouillon
  de commentaire » en Palier 2 (couverture perdue en contrats 1.2).
- Mode repli régénéré sur le Journal recalé (C10, AD-24).

Co-Authored-By: Claude Opus 5.5 <noreply@anthropic.com>
</commit_message>
<xml_diff>
--- a/demo/repli/passage/rapport-2026-10-09.pptx
+++ b/demo/repli/passage/rapport-2026-10-09.pptx
@@ -3583,7 +3583,7 @@
                     <a:p>
                       <a:r>
                         <a:rPr sz="1100"/>
-                        <a:t>2</a:t>
+                        <a:t>6</a:t>
                       </a:r>
                     </a:p>
                   </a:txBody>
@@ -3596,7 +3596,7 @@
                     <a:p>
                       <a:r>
                         <a:rPr sz="1100"/>
-                        <a:t>ENT-F, ENT-J</a:t>
+                        <a:t>ENT-E, ENT-F, ENT-G, ENT-H, ENT-I, ENT-J</a:t>
                       </a:r>
                     </a:p>
                   </a:txBody>
@@ -3632,7 +3632,7 @@
                     <a:p>
                       <a:r>
                         <a:rPr sz="1100"/>
-                        <a:t>5</a:t>
+                        <a:t>1</a:t>
                       </a:r>
                     </a:p>
                   </a:txBody>
@@ -3645,7 +3645,7 @@
                     <a:p>
                       <a:r>
                         <a:rPr sz="1100"/>
-                        <a:t>ENT-D, ENT-E, ENT-G, ENT-H, ENT-I</a:t>
+                        <a:t>ENT-D</a:t>
                       </a:r>
                     </a:p>
                   </a:txBody>
@@ -3739,7 +3739,7 @@
           <a:p>
             <a:r>
               <a:rPr sz="1400"/>
-              <a:t>Anomalies bloquantes ouvertes sur le Programme : 53 ; Entrées et Sorties de la Fenêtre glissante : 438 et 382</a:t>
+              <a:t>Anomalies bloquantes ouvertes sur le Programme : 13 ; Entrées et Sorties de la Fenêtre glissante : 438 et 403</a:t>
             </a:r>
           </a:p>
         </p:txBody>
@@ -3916,7 +3916,7 @@
                     <a:p>
                       <a:r>
                         <a:rPr sz="1100"/>
-                        <a:t>IND-1 : 21 (seuil ≥ 3)</a:t>
+                        <a:t>IND-1 : 4 (seuil ≥ 3)</a:t>
                       </a:r>
                     </a:p>
                   </a:txBody>
@@ -3978,7 +3978,7 @@
                     <a:p>
                       <a:r>
                         <a:rPr sz="1100"/>
-                        <a:t>IND-1 : 32 (seuil ≥ 3)</a:t>
+                        <a:t>IND-1 : 9 (seuil ≥ 3)</a:t>
                       </a:r>
                     </a:p>
                   </a:txBody>
@@ -4040,7 +4040,7 @@
                     <a:p>
                       <a:r>
                         <a:rPr sz="1100"/>
-                        <a:t>IND-4 : 16,7 % (seuil ≥ 10 %)</a:t>
+                        <a:t>IND-4 : 18 % (seuil ≥ 10 %)</a:t>
                       </a:r>
                     </a:p>
                   </a:txBody>
@@ -4131,16 +4131,16 @@
                       <a:r>
                         <a:rPr sz="1100" b="1">
                           <a:solidFill>
-                            <a:srgbClr val="FFFFFF"/>
+                            <a:srgbClr val="212121"/>
                           </a:solidFill>
                         </a:rPr>
-                        <a:t>Vert</a:t>
+                        <a:t>Jaune</a:t>
                       </a:r>
                     </a:p>
                   </a:txBody>
                   <a:tcPr>
                     <a:solidFill>
-                      <a:srgbClr val="2E7D32"/>
+                      <a:srgbClr val="F9A825"/>
                     </a:solidFill>
                   </a:tcPr>
                 </a:tc>
@@ -4164,7 +4164,7 @@
                     <a:p>
                       <a:r>
                         <a:rPr sz="1100"/>
-                        <a:t>—</a:t>
+                        <a:t>IND-6 : 1 (seuil ≥ 1)</a:t>
                       </a:r>
                     </a:p>
                   </a:txBody>
@@ -4255,16 +4255,16 @@
                       <a:r>
                         <a:rPr sz="1100" b="1">
                           <a:solidFill>
-                            <a:srgbClr val="FFFFFF"/>
+                            <a:srgbClr val="212121"/>
                           </a:solidFill>
                         </a:rPr>
-                        <a:t>Vert</a:t>
+                        <a:t>Jaune</a:t>
                       </a:r>
                     </a:p>
                   </a:txBody>
                   <a:tcPr>
                     <a:solidFill>
-                      <a:srgbClr val="2E7D32"/>
+                      <a:srgbClr val="F9A825"/>
                     </a:solidFill>
                   </a:tcPr>
                 </a:tc>
@@ -4288,7 +4288,7 @@
                     <a:p>
                       <a:r>
                         <a:rPr sz="1100"/>
-                        <a:t>—</a:t>
+                        <a:t>IND-6 : 1 (seuil ≥ 1)</a:t>
                       </a:r>
                     </a:p>
                   </a:txBody>
@@ -4317,16 +4317,16 @@
                       <a:r>
                         <a:rPr sz="1100" b="1">
                           <a:solidFill>
-                            <a:srgbClr val="FFFFFF"/>
+                            <a:srgbClr val="212121"/>
                           </a:solidFill>
                         </a:rPr>
-                        <a:t>Vert</a:t>
+                        <a:t>Jaune</a:t>
                       </a:r>
                     </a:p>
                   </a:txBody>
                   <a:tcPr>
                     <a:solidFill>
-                      <a:srgbClr val="2E7D32"/>
+                      <a:srgbClr val="F9A825"/>
                     </a:solidFill>
                   </a:tcPr>
                 </a:tc>
@@ -4350,7 +4350,7 @@
                     <a:p>
                       <a:r>
                         <a:rPr sz="1100"/>
-                        <a:t>—</a:t>
+                        <a:t>IND-6 : 1 (seuil ≥ 1)</a:t>
                       </a:r>
                     </a:p>
                   </a:txBody>
@@ -4379,16 +4379,16 @@
                       <a:r>
                         <a:rPr sz="1100" b="1">
                           <a:solidFill>
-                            <a:srgbClr val="FFFFFF"/>
+                            <a:srgbClr val="212121"/>
                           </a:solidFill>
                         </a:rPr>
-                        <a:t>Vert</a:t>
+                        <a:t>Jaune</a:t>
                       </a:r>
                     </a:p>
                   </a:txBody>
                   <a:tcPr>
                     <a:solidFill>
-                      <a:srgbClr val="2E7D32"/>
+                      <a:srgbClr val="F9A825"/>
                     </a:solidFill>
                   </a:tcPr>
                 </a:tc>
@@ -4412,7 +4412,7 @@
                     <a:p>
                       <a:r>
                         <a:rPr sz="1100"/>
-                        <a:t>—</a:t>
+                        <a:t>IND-6 : 1 (seuil ≥ 1)</a:t>
                       </a:r>
                     </a:p>
                   </a:txBody>
@@ -4554,13 +4554,7 @@
           <a:p>
             <a:r>
               <a:rPr sz="1200"/>
-              <a:t>IND-1 : 21 (seuil ≥ 3)</a:t>
-            </a:r>
-          </a:p>
-          <a:p>
-            <a:r>
-              <a:rPr sz="1200"/>
-              <a:t>IND-2 : 14 (seuil &gt; 10)</a:t>
+              <a:t>IND-1 : 4 (seuil ≥ 3)</a:t>
             </a:r>
           </a:p>
           <a:p>
@@ -4570,7 +4564,7 @@
             </a:r>
             <a:r>
               <a:rPr sz="1200"/>
-              <a:t>DEMO-2113</a:t>
+              <a:t>DEMO-3117</a:t>
             </a:r>
             <a:r>
               <a:rPr sz="1200"/>
@@ -4578,7 +4572,7 @@
             </a:r>
             <a:r>
               <a:rPr sz="1200"/>
-              <a:t>DEMO-2140</a:t>
+              <a:t>DEMO-3234</a:t>
             </a:r>
             <a:r>
               <a:rPr sz="1200"/>
@@ -4586,7 +4580,7 @@
             </a:r>
             <a:r>
               <a:rPr sz="1200"/>
-              <a:t>DEMO-2151</a:t>
+              <a:t>DEMO-3316</a:t>
             </a:r>
             <a:r>
               <a:rPr sz="1200"/>
@@ -4594,143 +4588,7 @@
             </a:r>
             <a:r>
               <a:rPr sz="1200"/>
-              <a:t>DEMO-2161</a:t>
-            </a:r>
-            <a:r>
-              <a:rPr sz="1200"/>
-              <a:t>, </a:t>
-            </a:r>
-            <a:r>
-              <a:rPr sz="1200"/>
-              <a:t>DEMO-2170</a:t>
-            </a:r>
-            <a:r>
-              <a:rPr sz="1200"/>
-              <a:t>, </a:t>
-            </a:r>
-            <a:r>
-              <a:rPr sz="1200"/>
-              <a:t>DEMO-2182</a:t>
-            </a:r>
-            <a:r>
-              <a:rPr sz="1200"/>
-              <a:t>, </a:t>
-            </a:r>
-            <a:r>
-              <a:rPr sz="1200"/>
-              <a:t>DEMO-2250</a:t>
-            </a:r>
-            <a:r>
-              <a:rPr sz="1200"/>
-              <a:t>, </a:t>
-            </a:r>
-            <a:r>
-              <a:rPr sz="1200"/>
-              <a:t>DEMO-2257</a:t>
-            </a:r>
-            <a:r>
-              <a:rPr sz="1200"/>
-              <a:t>, </a:t>
-            </a:r>
-            <a:r>
-              <a:rPr sz="1200"/>
-              <a:t>DEMO-2261</a:t>
-            </a:r>
-            <a:r>
-              <a:rPr sz="1200"/>
-              <a:t>, </a:t>
-            </a:r>
-            <a:r>
-              <a:rPr sz="1200"/>
-              <a:t>DEMO-2287</a:t>
-            </a:r>
-            <a:r>
-              <a:rPr sz="1200"/>
-              <a:t>, </a:t>
-            </a:r>
-            <a:r>
-              <a:rPr sz="1200"/>
-              <a:t>DEMO-2292</a:t>
-            </a:r>
-            <a:r>
-              <a:rPr sz="1200"/>
-              <a:t>, </a:t>
-            </a:r>
-            <a:r>
-              <a:rPr sz="1200"/>
-              <a:t>DEMO-2335</a:t>
-            </a:r>
-            <a:r>
-              <a:rPr sz="1200"/>
-              <a:t>, </a:t>
-            </a:r>
-            <a:r>
-              <a:rPr sz="1200"/>
-              <a:t>DEMO-2372</a:t>
-            </a:r>
-            <a:r>
-              <a:rPr sz="1200"/>
-              <a:t>, </a:t>
-            </a:r>
-            <a:r>
-              <a:rPr sz="1200"/>
-              <a:t>DEMO-2420</a:t>
-            </a:r>
-            <a:r>
-              <a:rPr sz="1200"/>
-              <a:t>, </a:t>
-            </a:r>
-            <a:r>
-              <a:rPr sz="1200"/>
-              <a:t>DEMO-2435</a:t>
-            </a:r>
-            <a:r>
-              <a:rPr sz="1200"/>
-              <a:t>, </a:t>
-            </a:r>
-            <a:r>
-              <a:rPr sz="1200"/>
-              <a:t>DEMO-2465</a:t>
-            </a:r>
-            <a:r>
-              <a:rPr sz="1200"/>
-              <a:t>, </a:t>
-            </a:r>
-            <a:r>
-              <a:rPr sz="1200"/>
-              <a:t>DEMO-2476</a:t>
-            </a:r>
-            <a:r>
-              <a:rPr sz="1200"/>
-              <a:t>, </a:t>
-            </a:r>
-            <a:r>
-              <a:rPr sz="1200"/>
-              <a:t>DEMO-2502</a:t>
-            </a:r>
-            <a:r>
-              <a:rPr sz="1200"/>
-              <a:t>, </a:t>
-            </a:r>
-            <a:r>
-              <a:rPr sz="1200"/>
-              <a:t>DEMO-2503</a:t>
-            </a:r>
-            <a:r>
-              <a:rPr sz="1200"/>
-              <a:t>, </a:t>
-            </a:r>
-            <a:r>
-              <a:rPr sz="1200"/>
-              <a:t>DEMO-2509</a:t>
-            </a:r>
-            <a:r>
-              <a:rPr sz="1200"/>
-              <a:t>, </a:t>
-            </a:r>
-            <a:r>
-              <a:rPr sz="1200"/>
-              <a:t>DEMO-2515</a:t>
+              <a:t>DEMO-3389</a:t>
             </a:r>
           </a:p>
         </p:txBody>
@@ -4806,7 +4664,7 @@
                     <a:p>
                       <a:r>
                         <a:rPr sz="900"/>
-                        <a:t>54</a:t>
+                        <a:t>40</a:t>
                       </a:r>
                     </a:p>
                   </a:txBody>
@@ -4834,7 +4692,7 @@
                     <a:p>
                       <a:r>
                         <a:rPr sz="900"/>
-                        <a:t>21</a:t>
+                        <a:t>4</a:t>
                       </a:r>
                     </a:p>
                   </a:txBody>
@@ -4890,7 +4748,7 @@
                     <a:p>
                       <a:r>
                         <a:rPr sz="900"/>
-                        <a:t>13</a:t>
+                        <a:t>17</a:t>
                       </a:r>
                     </a:p>
                   </a:txBody>
@@ -4918,7 +4776,7 @@
                     <a:p>
                       <a:r>
                         <a:rPr sz="900"/>
-                        <a:t>31</a:t>
+                        <a:t>39</a:t>
                       </a:r>
                     </a:p>
                   </a:txBody>
@@ -4946,7 +4804,7 @@
                     <a:p>
                       <a:r>
                         <a:rPr sz="900"/>
-                        <a:t>10</a:t>
+                        <a:t>6</a:t>
                       </a:r>
                     </a:p>
                   </a:txBody>
@@ -5030,7 +4888,7 @@
                     <a:p>
                       <a:r>
                         <a:rPr sz="900"/>
-                        <a:t>sans objet</a:t>
+                        <a:t>0 %</a:t>
                       </a:r>
                     </a:p>
                   </a:txBody>
@@ -5058,7 +4916,7 @@
                     <a:p>
                       <a:r>
                         <a:rPr sz="900"/>
-                        <a:t>0 %</a:t>
+                        <a:t>100 %</a:t>
                       </a:r>
                     </a:p>
                   </a:txBody>
@@ -5134,7 +4992,7 @@
           <a:p>
             <a:r>
               <a:rPr sz="1200"/>
-              <a:t>Sortie du rouge non projetable (règle IND-2)</a:t>
+              <a:t>Sortie du rouge estimée le 13/10/2026 (fourchette 13/10/2026 – non bornée), probabilité 50 % sous 10 Jours ouvrés</a:t>
             </a:r>
           </a:p>
         </p:txBody>
@@ -5208,25 +5066,7 @@
           <a:p>
             <a:r>
               <a:rPr sz="1200"/>
-              <a:t>IND-1 : 32 (seuil ≥ 3)</a:t>
-            </a:r>
-          </a:p>
-          <a:p>
-            <a:r>
-              <a:rPr sz="1200"/>
-              <a:t>IND-2 : 34 (seuil &gt; 10)</a:t>
-            </a:r>
-          </a:p>
-          <a:p>
-            <a:r>
-              <a:rPr sz="1200"/>
-              <a:t>IND-3 : 171 (seuil ≥ 20)</a:t>
-            </a:r>
-          </a:p>
-          <a:p>
-            <a:r>
-              <a:rPr sz="1200"/>
-              <a:t>IND-5 : 1 (seuil ≥ 1)</a:t>
+              <a:t>IND-1 : 9 (seuil ≥ 3)</a:t>
             </a:r>
           </a:p>
           <a:p>
@@ -5236,7 +5076,7 @@
             </a:r>
             <a:r>
               <a:rPr sz="1200"/>
-              <a:t>DEMO-407</a:t>
+              <a:t>DEMO-2842</a:t>
             </a:r>
             <a:r>
               <a:rPr sz="1200"/>
@@ -5244,7 +5084,7 @@
             </a:r>
             <a:r>
               <a:rPr sz="1200"/>
-              <a:t>DEMO-477</a:t>
+              <a:t>DEMO-2928</a:t>
             </a:r>
             <a:r>
               <a:rPr sz="1200"/>
@@ -5252,7 +5092,7 @@
             </a:r>
             <a:r>
               <a:rPr sz="1200"/>
-              <a:t>DEMO-890</a:t>
+              <a:t>DEMO-3079</a:t>
             </a:r>
             <a:r>
               <a:rPr sz="1200"/>
@@ -5260,7 +5100,7 @@
             </a:r>
             <a:r>
               <a:rPr sz="1200"/>
-              <a:t>DEMO-1023</a:t>
+              <a:t>DEMO-3128</a:t>
             </a:r>
             <a:r>
               <a:rPr sz="1200"/>
@@ -5268,7 +5108,7 @@
             </a:r>
             <a:r>
               <a:rPr sz="1200"/>
-              <a:t>DEMO-1282</a:t>
+              <a:t>DEMO-3160</a:t>
             </a:r>
             <a:r>
               <a:rPr sz="1200"/>
@@ -5276,7 +5116,7 @@
             </a:r>
             <a:r>
               <a:rPr sz="1200"/>
-              <a:t>DEMO-1305</a:t>
+              <a:t>DEMO-3232</a:t>
             </a:r>
             <a:r>
               <a:rPr sz="1200"/>
@@ -5284,7 +5124,7 @@
             </a:r>
             <a:r>
               <a:rPr sz="1200"/>
-              <a:t>DEMO-1325</a:t>
+              <a:t>DEMO-3307</a:t>
             </a:r>
             <a:r>
               <a:rPr sz="1200"/>
@@ -5292,7 +5132,7 @@
             </a:r>
             <a:r>
               <a:rPr sz="1200"/>
-              <a:t>DEMO-1326</a:t>
+              <a:t>DEMO-3430</a:t>
             </a:r>
             <a:r>
               <a:rPr sz="1200"/>
@@ -5300,1567 +5140,7 @@
             </a:r>
             <a:r>
               <a:rPr sz="1200"/>
-              <a:t>DEMO-1331</a:t>
-            </a:r>
-            <a:r>
-              <a:rPr sz="1200"/>
-              <a:t>, </a:t>
-            </a:r>
-            <a:r>
-              <a:rPr sz="1200"/>
-              <a:t>DEMO-1349</a:t>
-            </a:r>
-            <a:r>
-              <a:rPr sz="1200"/>
-              <a:t>, </a:t>
-            </a:r>
-            <a:r>
-              <a:rPr sz="1200"/>
-              <a:t>DEMO-1442</a:t>
-            </a:r>
-            <a:r>
-              <a:rPr sz="1200"/>
-              <a:t>, </a:t>
-            </a:r>
-            <a:r>
-              <a:rPr sz="1200"/>
-              <a:t>DEMO-1628</a:t>
-            </a:r>
-            <a:r>
-              <a:rPr sz="1200"/>
-              <a:t>, </a:t>
-            </a:r>
-            <a:r>
-              <a:rPr sz="1200"/>
-              <a:t>DEMO-1633</a:t>
-            </a:r>
-            <a:r>
-              <a:rPr sz="1200"/>
-              <a:t>, </a:t>
-            </a:r>
-            <a:r>
-              <a:rPr sz="1200"/>
-              <a:t>DEMO-1696</a:t>
-            </a:r>
-            <a:r>
-              <a:rPr sz="1200"/>
-              <a:t>, </a:t>
-            </a:r>
-            <a:r>
-              <a:rPr sz="1200"/>
-              <a:t>DEMO-1739</a:t>
-            </a:r>
-            <a:r>
-              <a:rPr sz="1200"/>
-              <a:t>, </a:t>
-            </a:r>
-            <a:r>
-              <a:rPr sz="1200"/>
-              <a:t>DEMO-1824</a:t>
-            </a:r>
-            <a:r>
-              <a:rPr sz="1200"/>
-              <a:t>, </a:t>
-            </a:r>
-            <a:r>
-              <a:rPr sz="1200"/>
-              <a:t>DEMO-1837</a:t>
-            </a:r>
-            <a:r>
-              <a:rPr sz="1200"/>
-              <a:t>, </a:t>
-            </a:r>
-            <a:r>
-              <a:rPr sz="1200"/>
-              <a:t>DEMO-2167</a:t>
-            </a:r>
-            <a:r>
-              <a:rPr sz="1200"/>
-              <a:t>, </a:t>
-            </a:r>
-            <a:r>
-              <a:rPr sz="1200"/>
-              <a:t>DEMO-2212</a:t>
-            </a:r>
-            <a:r>
-              <a:rPr sz="1200"/>
-              <a:t>, </a:t>
-            </a:r>
-            <a:r>
-              <a:rPr sz="1200"/>
-              <a:t>DEMO-2268</a:t>
-            </a:r>
-            <a:r>
-              <a:rPr sz="1200"/>
-              <a:t>, </a:t>
-            </a:r>
-            <a:r>
-              <a:rPr sz="1200"/>
-              <a:t>DEMO-2334</a:t>
-            </a:r>
-            <a:r>
-              <a:rPr sz="1200"/>
-              <a:t>, </a:t>
-            </a:r>
-            <a:r>
-              <a:rPr sz="1200"/>
-              <a:t>DEMO-2644</a:t>
-            </a:r>
-            <a:r>
-              <a:rPr sz="1200"/>
-              <a:t>, </a:t>
-            </a:r>
-            <a:r>
-              <a:rPr sz="1200"/>
-              <a:t>DEMO-2666</a:t>
-            </a:r>
-            <a:r>
-              <a:rPr sz="1200"/>
-              <a:t>, </a:t>
-            </a:r>
-            <a:r>
-              <a:rPr sz="1200"/>
-              <a:t>DEMO-2689</a:t>
-            </a:r>
-            <a:r>
-              <a:rPr sz="1200"/>
-              <a:t>, </a:t>
-            </a:r>
-            <a:r>
-              <a:rPr sz="1200"/>
-              <a:t>DEMO-2811</a:t>
-            </a:r>
-            <a:r>
-              <a:rPr sz="1200"/>
-              <a:t>, </a:t>
-            </a:r>
-            <a:r>
-              <a:rPr sz="1200"/>
-              <a:t>DEMO-2942</a:t>
-            </a:r>
-            <a:r>
-              <a:rPr sz="1200"/>
-              <a:t>, </a:t>
-            </a:r>
-            <a:r>
-              <a:rPr sz="1200"/>
-              <a:t>DEMO-3070</a:t>
-            </a:r>
-            <a:r>
-              <a:rPr sz="1200"/>
-              <a:t>, </a:t>
-            </a:r>
-            <a:r>
-              <a:rPr sz="1200"/>
-              <a:t>DEMO-3148</a:t>
-            </a:r>
-            <a:r>
-              <a:rPr sz="1200"/>
-              <a:t>, </a:t>
-            </a:r>
-            <a:r>
-              <a:rPr sz="1200"/>
-              <a:t>DEMO-3208</a:t>
-            </a:r>
-            <a:r>
-              <a:rPr sz="1200"/>
-              <a:t>, </a:t>
-            </a:r>
-            <a:r>
-              <a:rPr sz="1200"/>
-              <a:t>DEMO-3283</a:t>
-            </a:r>
-            <a:r>
-              <a:rPr sz="1200"/>
-              <a:t>, </a:t>
-            </a:r>
-            <a:r>
-              <a:rPr sz="1200"/>
-              <a:t>DEMO-3309</a:t>
-            </a:r>
-            <a:r>
-              <a:rPr sz="1200"/>
-              <a:t>, </a:t>
-            </a:r>
-            <a:r>
-              <a:rPr sz="1200"/>
-              <a:t>DEMO-3344</a:t>
-            </a:r>
-            <a:r>
-              <a:rPr sz="1200"/>
-              <a:t>, </a:t>
-            </a:r>
-            <a:r>
-              <a:rPr sz="1200"/>
-              <a:t>DEMO-465</a:t>
-            </a:r>
-            <a:r>
-              <a:rPr sz="1200"/>
-              <a:t>, </a:t>
-            </a:r>
-            <a:r>
-              <a:rPr sz="1200"/>
-              <a:t>DEMO-473</a:t>
-            </a:r>
-            <a:r>
-              <a:rPr sz="1200"/>
-              <a:t>, </a:t>
-            </a:r>
-            <a:r>
-              <a:rPr sz="1200"/>
-              <a:t>DEMO-503</a:t>
-            </a:r>
-            <a:r>
-              <a:rPr sz="1200"/>
-              <a:t>, </a:t>
-            </a:r>
-            <a:r>
-              <a:rPr sz="1200"/>
-              <a:t>DEMO-506</a:t>
-            </a:r>
-            <a:r>
-              <a:rPr sz="1200"/>
-              <a:t>, </a:t>
-            </a:r>
-            <a:r>
-              <a:rPr sz="1200"/>
-              <a:t>DEMO-580</a:t>
-            </a:r>
-            <a:r>
-              <a:rPr sz="1200"/>
-              <a:t>, </a:t>
-            </a:r>
-            <a:r>
-              <a:rPr sz="1200"/>
-              <a:t>DEMO-602</a:t>
-            </a:r>
-            <a:r>
-              <a:rPr sz="1200"/>
-              <a:t>, </a:t>
-            </a:r>
-            <a:r>
-              <a:rPr sz="1200"/>
-              <a:t>DEMO-644</a:t>
-            </a:r>
-            <a:r>
-              <a:rPr sz="1200"/>
-              <a:t>, </a:t>
-            </a:r>
-            <a:r>
-              <a:rPr sz="1200"/>
-              <a:t>DEMO-647</a:t>
-            </a:r>
-            <a:r>
-              <a:rPr sz="1200"/>
-              <a:t>, </a:t>
-            </a:r>
-            <a:r>
-              <a:rPr sz="1200"/>
-              <a:t>DEMO-653</a:t>
-            </a:r>
-            <a:r>
-              <a:rPr sz="1200"/>
-              <a:t>, </a:t>
-            </a:r>
-            <a:r>
-              <a:rPr sz="1200"/>
-              <a:t>DEMO-683</a:t>
-            </a:r>
-            <a:r>
-              <a:rPr sz="1200"/>
-              <a:t>, </a:t>
-            </a:r>
-            <a:r>
-              <a:rPr sz="1200"/>
-              <a:t>DEMO-709</a:t>
-            </a:r>
-            <a:r>
-              <a:rPr sz="1200"/>
-              <a:t>, </a:t>
-            </a:r>
-            <a:r>
-              <a:rPr sz="1200"/>
-              <a:t>DEMO-766</a:t>
-            </a:r>
-            <a:r>
-              <a:rPr sz="1200"/>
-              <a:t>, </a:t>
-            </a:r>
-            <a:r>
-              <a:rPr sz="1200"/>
-              <a:t>DEMO-788</a:t>
-            </a:r>
-            <a:r>
-              <a:rPr sz="1200"/>
-              <a:t>, </a:t>
-            </a:r>
-            <a:r>
-              <a:rPr sz="1200"/>
-              <a:t>DEMO-847</a:t>
-            </a:r>
-            <a:r>
-              <a:rPr sz="1200"/>
-              <a:t>, </a:t>
-            </a:r>
-            <a:r>
-              <a:rPr sz="1200"/>
-              <a:t>DEMO-881</a:t>
-            </a:r>
-            <a:r>
-              <a:rPr sz="1200"/>
-              <a:t>, </a:t>
-            </a:r>
-            <a:r>
-              <a:rPr sz="1200"/>
-              <a:t>DEMO-913</a:t>
-            </a:r>
-            <a:r>
-              <a:rPr sz="1200"/>
-              <a:t>, </a:t>
-            </a:r>
-            <a:r>
-              <a:rPr sz="1200"/>
-              <a:t>DEMO-936</a:t>
-            </a:r>
-            <a:r>
-              <a:rPr sz="1200"/>
-              <a:t>, </a:t>
-            </a:r>
-            <a:r>
-              <a:rPr sz="1200"/>
-              <a:t>DEMO-956</a:t>
-            </a:r>
-            <a:r>
-              <a:rPr sz="1200"/>
-              <a:t>, </a:t>
-            </a:r>
-            <a:r>
-              <a:rPr sz="1200"/>
-              <a:t>DEMO-961</a:t>
-            </a:r>
-            <a:r>
-              <a:rPr sz="1200"/>
-              <a:t>, </a:t>
-            </a:r>
-            <a:r>
-              <a:rPr sz="1200"/>
-              <a:t>DEMO-1006</a:t>
-            </a:r>
-            <a:r>
-              <a:rPr sz="1200"/>
-              <a:t>, </a:t>
-            </a:r>
-            <a:r>
-              <a:rPr sz="1200"/>
-              <a:t>DEMO-1013</a:t>
-            </a:r>
-            <a:r>
-              <a:rPr sz="1200"/>
-              <a:t>, </a:t>
-            </a:r>
-            <a:r>
-              <a:rPr sz="1200"/>
-              <a:t>DEMO-1051</a:t>
-            </a:r>
-            <a:r>
-              <a:rPr sz="1200"/>
-              <a:t>, </a:t>
-            </a:r>
-            <a:r>
-              <a:rPr sz="1200"/>
-              <a:t>DEMO-1070</a:t>
-            </a:r>
-            <a:r>
-              <a:rPr sz="1200"/>
-              <a:t>, </a:t>
-            </a:r>
-            <a:r>
-              <a:rPr sz="1200"/>
-              <a:t>DEMO-1074</a:t>
-            </a:r>
-            <a:r>
-              <a:rPr sz="1200"/>
-              <a:t>, </a:t>
-            </a:r>
-            <a:r>
-              <a:rPr sz="1200"/>
-              <a:t>DEMO-1093</a:t>
-            </a:r>
-            <a:r>
-              <a:rPr sz="1200"/>
-              <a:t>, </a:t>
-            </a:r>
-            <a:r>
-              <a:rPr sz="1200"/>
-              <a:t>DEMO-1106</a:t>
-            </a:r>
-            <a:r>
-              <a:rPr sz="1200"/>
-              <a:t>, </a:t>
-            </a:r>
-            <a:r>
-              <a:rPr sz="1200"/>
-              <a:t>DEMO-1114</a:t>
-            </a:r>
-            <a:r>
-              <a:rPr sz="1200"/>
-              <a:t>, </a:t>
-            </a:r>
-            <a:r>
-              <a:rPr sz="1200"/>
-              <a:t>DEMO-1124</a:t>
-            </a:r>
-            <a:r>
-              <a:rPr sz="1200"/>
-              <a:t>, </a:t>
-            </a:r>
-            <a:r>
-              <a:rPr sz="1200"/>
-              <a:t>DEMO-1127</a:t>
-            </a:r>
-            <a:r>
-              <a:rPr sz="1200"/>
-              <a:t>, </a:t>
-            </a:r>
-            <a:r>
-              <a:rPr sz="1200"/>
-              <a:t>DEMO-1188</a:t>
-            </a:r>
-            <a:r>
-              <a:rPr sz="1200"/>
-              <a:t>, </a:t>
-            </a:r>
-            <a:r>
-              <a:rPr sz="1200"/>
-              <a:t>DEMO-1204</a:t>
-            </a:r>
-            <a:r>
-              <a:rPr sz="1200"/>
-              <a:t>, </a:t>
-            </a:r>
-            <a:r>
-              <a:rPr sz="1200"/>
-              <a:t>DEMO-1215</a:t>
-            </a:r>
-            <a:r>
-              <a:rPr sz="1200"/>
-              <a:t>, </a:t>
-            </a:r>
-            <a:r>
-              <a:rPr sz="1200"/>
-              <a:t>DEMO-1225</a:t>
-            </a:r>
-            <a:r>
-              <a:rPr sz="1200"/>
-              <a:t>, </a:t>
-            </a:r>
-            <a:r>
-              <a:rPr sz="1200"/>
-              <a:t>DEMO-1275</a:t>
-            </a:r>
-            <a:r>
-              <a:rPr sz="1200"/>
-              <a:t>, </a:t>
-            </a:r>
-            <a:r>
-              <a:rPr sz="1200"/>
-              <a:t>DEMO-1299</a:t>
-            </a:r>
-            <a:r>
-              <a:rPr sz="1200"/>
-              <a:t>, </a:t>
-            </a:r>
-            <a:r>
-              <a:rPr sz="1200"/>
-              <a:t>DEMO-1309</a:t>
-            </a:r>
-            <a:r>
-              <a:rPr sz="1200"/>
-              <a:t>, </a:t>
-            </a:r>
-            <a:r>
-              <a:rPr sz="1200"/>
-              <a:t>DEMO-1358</a:t>
-            </a:r>
-            <a:r>
-              <a:rPr sz="1200"/>
-              <a:t>, </a:t>
-            </a:r>
-            <a:r>
-              <a:rPr sz="1200"/>
-              <a:t>DEMO-1368</a:t>
-            </a:r>
-            <a:r>
-              <a:rPr sz="1200"/>
-              <a:t>, </a:t>
-            </a:r>
-            <a:r>
-              <a:rPr sz="1200"/>
-              <a:t>DEMO-1383</a:t>
-            </a:r>
-            <a:r>
-              <a:rPr sz="1200"/>
-              <a:t>, </a:t>
-            </a:r>
-            <a:r>
-              <a:rPr sz="1200"/>
-              <a:t>DEMO-1384</a:t>
-            </a:r>
-            <a:r>
-              <a:rPr sz="1200"/>
-              <a:t>, </a:t>
-            </a:r>
-            <a:r>
-              <a:rPr sz="1200"/>
-              <a:t>DEMO-1427</a:t>
-            </a:r>
-            <a:r>
-              <a:rPr sz="1200"/>
-              <a:t>, </a:t>
-            </a:r>
-            <a:r>
-              <a:rPr sz="1200"/>
-              <a:t>DEMO-1432</a:t>
-            </a:r>
-            <a:r>
-              <a:rPr sz="1200"/>
-              <a:t>, </a:t>
-            </a:r>
-            <a:r>
-              <a:rPr sz="1200"/>
-              <a:t>DEMO-1436</a:t>
-            </a:r>
-            <a:r>
-              <a:rPr sz="1200"/>
-              <a:t>, </a:t>
-            </a:r>
-            <a:r>
-              <a:rPr sz="1200"/>
-              <a:t>DEMO-1454</a:t>
-            </a:r>
-            <a:r>
-              <a:rPr sz="1200"/>
-              <a:t>, </a:t>
-            </a:r>
-            <a:r>
-              <a:rPr sz="1200"/>
-              <a:t>DEMO-1464</a:t>
-            </a:r>
-            <a:r>
-              <a:rPr sz="1200"/>
-              <a:t>, </a:t>
-            </a:r>
-            <a:r>
-              <a:rPr sz="1200"/>
-              <a:t>DEMO-1469</a:t>
-            </a:r>
-            <a:r>
-              <a:rPr sz="1200"/>
-              <a:t>, </a:t>
-            </a:r>
-            <a:r>
-              <a:rPr sz="1200"/>
-              <a:t>DEMO-1471</a:t>
-            </a:r>
-            <a:r>
-              <a:rPr sz="1200"/>
-              <a:t>, </a:t>
-            </a:r>
-            <a:r>
-              <a:rPr sz="1200"/>
-              <a:t>DEMO-1489</a:t>
-            </a:r>
-            <a:r>
-              <a:rPr sz="1200"/>
-              <a:t>, </a:t>
-            </a:r>
-            <a:r>
-              <a:rPr sz="1200"/>
-              <a:t>DEMO-1494</a:t>
-            </a:r>
-            <a:r>
-              <a:rPr sz="1200"/>
-              <a:t>, </a:t>
-            </a:r>
-            <a:r>
-              <a:rPr sz="1200"/>
-              <a:t>DEMO-1553</a:t>
-            </a:r>
-            <a:r>
-              <a:rPr sz="1200"/>
-              <a:t>, </a:t>
-            </a:r>
-            <a:r>
-              <a:rPr sz="1200"/>
-              <a:t>DEMO-1555</a:t>
-            </a:r>
-            <a:r>
-              <a:rPr sz="1200"/>
-              <a:t>, </a:t>
-            </a:r>
-            <a:r>
-              <a:rPr sz="1200"/>
-              <a:t>DEMO-1571</a:t>
-            </a:r>
-            <a:r>
-              <a:rPr sz="1200"/>
-              <a:t>, </a:t>
-            </a:r>
-            <a:r>
-              <a:rPr sz="1200"/>
-              <a:t>DEMO-1583</a:t>
-            </a:r>
-            <a:r>
-              <a:rPr sz="1200"/>
-              <a:t>, </a:t>
-            </a:r>
-            <a:r>
-              <a:rPr sz="1200"/>
-              <a:t>DEMO-1597</a:t>
-            </a:r>
-            <a:r>
-              <a:rPr sz="1200"/>
-              <a:t>, </a:t>
-            </a:r>
-            <a:r>
-              <a:rPr sz="1200"/>
-              <a:t>DEMO-1599</a:t>
-            </a:r>
-            <a:r>
-              <a:rPr sz="1200"/>
-              <a:t>, </a:t>
-            </a:r>
-            <a:r>
-              <a:rPr sz="1200"/>
-              <a:t>DEMO-1613</a:t>
-            </a:r>
-            <a:r>
-              <a:rPr sz="1200"/>
-              <a:t>, </a:t>
-            </a:r>
-            <a:r>
-              <a:rPr sz="1200"/>
-              <a:t>DEMO-1649</a:t>
-            </a:r>
-            <a:r>
-              <a:rPr sz="1200"/>
-              <a:t>, </a:t>
-            </a:r>
-            <a:r>
-              <a:rPr sz="1200"/>
-              <a:t>DEMO-1654</a:t>
-            </a:r>
-            <a:r>
-              <a:rPr sz="1200"/>
-              <a:t>, </a:t>
-            </a:r>
-            <a:r>
-              <a:rPr sz="1200"/>
-              <a:t>DEMO-1663</a:t>
-            </a:r>
-            <a:r>
-              <a:rPr sz="1200"/>
-              <a:t>, </a:t>
-            </a:r>
-            <a:r>
-              <a:rPr sz="1200"/>
-              <a:t>DEMO-1671</a:t>
-            </a:r>
-            <a:r>
-              <a:rPr sz="1200"/>
-              <a:t>, </a:t>
-            </a:r>
-            <a:r>
-              <a:rPr sz="1200"/>
-              <a:t>DEMO-1692</a:t>
-            </a:r>
-            <a:r>
-              <a:rPr sz="1200"/>
-              <a:t>, </a:t>
-            </a:r>
-            <a:r>
-              <a:rPr sz="1200"/>
-              <a:t>DEMO-1733</a:t>
-            </a:r>
-            <a:r>
-              <a:rPr sz="1200"/>
-              <a:t>, </a:t>
-            </a:r>
-            <a:r>
-              <a:rPr sz="1200"/>
-              <a:t>DEMO-1755</a:t>
-            </a:r>
-            <a:r>
-              <a:rPr sz="1200"/>
-              <a:t>, </a:t>
-            </a:r>
-            <a:r>
-              <a:rPr sz="1200"/>
-              <a:t>DEMO-1768</a:t>
-            </a:r>
-            <a:r>
-              <a:rPr sz="1200"/>
-              <a:t>, </a:t>
-            </a:r>
-            <a:r>
-              <a:rPr sz="1200"/>
-              <a:t>DEMO-1785</a:t>
-            </a:r>
-            <a:r>
-              <a:rPr sz="1200"/>
-              <a:t>, </a:t>
-            </a:r>
-            <a:r>
-              <a:rPr sz="1200"/>
-              <a:t>DEMO-1812</a:t>
-            </a:r>
-            <a:r>
-              <a:rPr sz="1200"/>
-              <a:t>, </a:t>
-            </a:r>
-            <a:r>
-              <a:rPr sz="1200"/>
-              <a:t>DEMO-1859</a:t>
-            </a:r>
-            <a:r>
-              <a:rPr sz="1200"/>
-              <a:t>, </a:t>
-            </a:r>
-            <a:r>
-              <a:rPr sz="1200"/>
-              <a:t>DEMO-1874</a:t>
-            </a:r>
-            <a:r>
-              <a:rPr sz="1200"/>
-              <a:t>, </a:t>
-            </a:r>
-            <a:r>
-              <a:rPr sz="1200"/>
-              <a:t>DEMO-1889</a:t>
-            </a:r>
-            <a:r>
-              <a:rPr sz="1200"/>
-              <a:t>, </a:t>
-            </a:r>
-            <a:r>
-              <a:rPr sz="1200"/>
-              <a:t>DEMO-1935</a:t>
-            </a:r>
-            <a:r>
-              <a:rPr sz="1200"/>
-              <a:t>, </a:t>
-            </a:r>
-            <a:r>
-              <a:rPr sz="1200"/>
-              <a:t>DEMO-1938</a:t>
-            </a:r>
-            <a:r>
-              <a:rPr sz="1200"/>
-              <a:t>, </a:t>
-            </a:r>
-            <a:r>
-              <a:rPr sz="1200"/>
-              <a:t>DEMO-1984</a:t>
-            </a:r>
-            <a:r>
-              <a:rPr sz="1200"/>
-              <a:t>, </a:t>
-            </a:r>
-            <a:r>
-              <a:rPr sz="1200"/>
-              <a:t>DEMO-1990</a:t>
-            </a:r>
-            <a:r>
-              <a:rPr sz="1200"/>
-              <a:t>, </a:t>
-            </a:r>
-            <a:r>
-              <a:rPr sz="1200"/>
-              <a:t>DEMO-2017</a:t>
-            </a:r>
-            <a:r>
-              <a:rPr sz="1200"/>
-              <a:t>, </a:t>
-            </a:r>
-            <a:r>
-              <a:rPr sz="1200"/>
-              <a:t>DEMO-2037</a:t>
-            </a:r>
-            <a:r>
-              <a:rPr sz="1200"/>
-              <a:t>, </a:t>
-            </a:r>
-            <a:r>
-              <a:rPr sz="1200"/>
-              <a:t>DEMO-2055</a:t>
-            </a:r>
-            <a:r>
-              <a:rPr sz="1200"/>
-              <a:t>, </a:t>
-            </a:r>
-            <a:r>
-              <a:rPr sz="1200"/>
-              <a:t>DEMO-2058</a:t>
-            </a:r>
-            <a:r>
-              <a:rPr sz="1200"/>
-              <a:t>, </a:t>
-            </a:r>
-            <a:r>
-              <a:rPr sz="1200"/>
-              <a:t>DEMO-2063</a:t>
-            </a:r>
-            <a:r>
-              <a:rPr sz="1200"/>
-              <a:t>, </a:t>
-            </a:r>
-            <a:r>
-              <a:rPr sz="1200"/>
-              <a:t>DEMO-2068</a:t>
-            </a:r>
-            <a:r>
-              <a:rPr sz="1200"/>
-              <a:t>, </a:t>
-            </a:r>
-            <a:r>
-              <a:rPr sz="1200"/>
-              <a:t>DEMO-2078</a:t>
-            </a:r>
-            <a:r>
-              <a:rPr sz="1200"/>
-              <a:t>, </a:t>
-            </a:r>
-            <a:r>
-              <a:rPr sz="1200"/>
-              <a:t>DEMO-2091</a:t>
-            </a:r>
-            <a:r>
-              <a:rPr sz="1200"/>
-              <a:t>, </a:t>
-            </a:r>
-            <a:r>
-              <a:rPr sz="1200"/>
-              <a:t>DEMO-2098</a:t>
-            </a:r>
-            <a:r>
-              <a:rPr sz="1200"/>
-              <a:t>, </a:t>
-            </a:r>
-            <a:r>
-              <a:rPr sz="1200"/>
-              <a:t>DEMO-2104</a:t>
-            </a:r>
-            <a:r>
-              <a:rPr sz="1200"/>
-              <a:t>, </a:t>
-            </a:r>
-            <a:r>
-              <a:rPr sz="1200"/>
-              <a:t>DEMO-2110</a:t>
-            </a:r>
-            <a:r>
-              <a:rPr sz="1200"/>
-              <a:t>, </a:t>
-            </a:r>
-            <a:r>
-              <a:rPr sz="1200"/>
-              <a:t>DEMO-2111</a:t>
-            </a:r>
-            <a:r>
-              <a:rPr sz="1200"/>
-              <a:t>, </a:t>
-            </a:r>
-            <a:r>
-              <a:rPr sz="1200"/>
-              <a:t>DEMO-2125</a:t>
-            </a:r>
-            <a:r>
-              <a:rPr sz="1200"/>
-              <a:t>, </a:t>
-            </a:r>
-            <a:r>
-              <a:rPr sz="1200"/>
-              <a:t>DEMO-2143</a:t>
-            </a:r>
-            <a:r>
-              <a:rPr sz="1200"/>
-              <a:t>, </a:t>
-            </a:r>
-            <a:r>
-              <a:rPr sz="1200"/>
-              <a:t>DEMO-2253</a:t>
-            </a:r>
-            <a:r>
-              <a:rPr sz="1200"/>
-              <a:t>, </a:t>
-            </a:r>
-            <a:r>
-              <a:rPr sz="1200"/>
-              <a:t>DEMO-2288</a:t>
-            </a:r>
-            <a:r>
-              <a:rPr sz="1200"/>
-              <a:t>, </a:t>
-            </a:r>
-            <a:r>
-              <a:rPr sz="1200"/>
-              <a:t>DEMO-2298</a:t>
-            </a:r>
-            <a:r>
-              <a:rPr sz="1200"/>
-              <a:t>, </a:t>
-            </a:r>
-            <a:r>
-              <a:rPr sz="1200"/>
-              <a:t>DEMO-2306</a:t>
-            </a:r>
-            <a:r>
-              <a:rPr sz="1200"/>
-              <a:t>, </a:t>
-            </a:r>
-            <a:r>
-              <a:rPr sz="1200"/>
-              <a:t>DEMO-2328</a:t>
-            </a:r>
-            <a:r>
-              <a:rPr sz="1200"/>
-              <a:t>, </a:t>
-            </a:r>
-            <a:r>
-              <a:rPr sz="1200"/>
-              <a:t>DEMO-2337</a:t>
-            </a:r>
-            <a:r>
-              <a:rPr sz="1200"/>
-              <a:t>, </a:t>
-            </a:r>
-            <a:r>
-              <a:rPr sz="1200"/>
-              <a:t>DEMO-2374</a:t>
-            </a:r>
-            <a:r>
-              <a:rPr sz="1200"/>
-              <a:t>, </a:t>
-            </a:r>
-            <a:r>
-              <a:rPr sz="1200"/>
-              <a:t>DEMO-2383</a:t>
-            </a:r>
-            <a:r>
-              <a:rPr sz="1200"/>
-              <a:t>, </a:t>
-            </a:r>
-            <a:r>
-              <a:rPr sz="1200"/>
-              <a:t>DEMO-2385</a:t>
-            </a:r>
-            <a:r>
-              <a:rPr sz="1200"/>
-              <a:t>, </a:t>
-            </a:r>
-            <a:r>
-              <a:rPr sz="1200"/>
-              <a:t>DEMO-2396</a:t>
-            </a:r>
-            <a:r>
-              <a:rPr sz="1200"/>
-              <a:t>, </a:t>
-            </a:r>
-            <a:r>
-              <a:rPr sz="1200"/>
-              <a:t>DEMO-2407</a:t>
-            </a:r>
-            <a:r>
-              <a:rPr sz="1200"/>
-              <a:t>, </a:t>
-            </a:r>
-            <a:r>
-              <a:rPr sz="1200"/>
-              <a:t>DEMO-2417</a:t>
-            </a:r>
-            <a:r>
-              <a:rPr sz="1200"/>
-              <a:t>, </a:t>
-            </a:r>
-            <a:r>
-              <a:rPr sz="1200"/>
-              <a:t>DEMO-2425</a:t>
-            </a:r>
-            <a:r>
-              <a:rPr sz="1200"/>
-              <a:t>, </a:t>
-            </a:r>
-            <a:r>
-              <a:rPr sz="1200"/>
-              <a:t>DEMO-2464</a:t>
-            </a:r>
-            <a:r>
-              <a:rPr sz="1200"/>
-              <a:t>, </a:t>
-            </a:r>
-            <a:r>
-              <a:rPr sz="1200"/>
-              <a:t>DEMO-2482</a:t>
-            </a:r>
-            <a:r>
-              <a:rPr sz="1200"/>
-              <a:t>, </a:t>
-            </a:r>
-            <a:r>
-              <a:rPr sz="1200"/>
-              <a:t>DEMO-2517</a:t>
-            </a:r>
-            <a:r>
-              <a:rPr sz="1200"/>
-              <a:t>, </a:t>
-            </a:r>
-            <a:r>
-              <a:rPr sz="1200"/>
-              <a:t>DEMO-2530</a:t>
-            </a:r>
-            <a:r>
-              <a:rPr sz="1200"/>
-              <a:t>, </a:t>
-            </a:r>
-            <a:r>
-              <a:rPr sz="1200"/>
-              <a:t>DEMO-2537</a:t>
-            </a:r>
-            <a:r>
-              <a:rPr sz="1200"/>
-              <a:t>, </a:t>
-            </a:r>
-            <a:r>
-              <a:rPr sz="1200"/>
-              <a:t>DEMO-2538</a:t>
-            </a:r>
-            <a:r>
-              <a:rPr sz="1200"/>
-              <a:t>, </a:t>
-            </a:r>
-            <a:r>
-              <a:rPr sz="1200"/>
-              <a:t>DEMO-2543</a:t>
-            </a:r>
-            <a:r>
-              <a:rPr sz="1200"/>
-              <a:t>, </a:t>
-            </a:r>
-            <a:r>
-              <a:rPr sz="1200"/>
-              <a:t>DEMO-2555</a:t>
-            </a:r>
-            <a:r>
-              <a:rPr sz="1200"/>
-              <a:t>, </a:t>
-            </a:r>
-            <a:r>
-              <a:rPr sz="1200"/>
-              <a:t>DEMO-2557</a:t>
-            </a:r>
-            <a:r>
-              <a:rPr sz="1200"/>
-              <a:t>, </a:t>
-            </a:r>
-            <a:r>
-              <a:rPr sz="1200"/>
-              <a:t>DEMO-2591</a:t>
-            </a:r>
-            <a:r>
-              <a:rPr sz="1200"/>
-              <a:t>, </a:t>
-            </a:r>
-            <a:r>
-              <a:rPr sz="1200"/>
-              <a:t>DEMO-2600</a:t>
-            </a:r>
-            <a:r>
-              <a:rPr sz="1200"/>
-              <a:t>, </a:t>
-            </a:r>
-            <a:r>
-              <a:rPr sz="1200"/>
-              <a:t>DEMO-2606</a:t>
-            </a:r>
-            <a:r>
-              <a:rPr sz="1200"/>
-              <a:t>, </a:t>
-            </a:r>
-            <a:r>
-              <a:rPr sz="1200"/>
-              <a:t>DEMO-2615</a:t>
-            </a:r>
-            <a:r>
-              <a:rPr sz="1200"/>
-              <a:t>, </a:t>
-            </a:r>
-            <a:r>
-              <a:rPr sz="1200"/>
-              <a:t>DEMO-2621</a:t>
-            </a:r>
-            <a:r>
-              <a:rPr sz="1200"/>
-              <a:t>, </a:t>
-            </a:r>
-            <a:r>
-              <a:rPr sz="1200"/>
-              <a:t>DEMO-2630</a:t>
-            </a:r>
-            <a:r>
-              <a:rPr sz="1200"/>
-              <a:t>, </a:t>
-            </a:r>
-            <a:r>
-              <a:rPr sz="1200"/>
-              <a:t>DEMO-2635</a:t>
-            </a:r>
-            <a:r>
-              <a:rPr sz="1200"/>
-              <a:t>, </a:t>
-            </a:r>
-            <a:r>
-              <a:rPr sz="1200"/>
-              <a:t>DEMO-2643</a:t>
-            </a:r>
-            <a:r>
-              <a:rPr sz="1200"/>
-              <a:t>, </a:t>
-            </a:r>
-            <a:r>
-              <a:rPr sz="1200"/>
-              <a:t>DEMO-2663</a:t>
-            </a:r>
-            <a:r>
-              <a:rPr sz="1200"/>
-              <a:t>, </a:t>
-            </a:r>
-            <a:r>
-              <a:rPr sz="1200"/>
-              <a:t>DEMO-2677</a:t>
-            </a:r>
-            <a:r>
-              <a:rPr sz="1200"/>
-              <a:t>, </a:t>
-            </a:r>
-            <a:r>
-              <a:rPr sz="1200"/>
-              <a:t>DEMO-2681</a:t>
-            </a:r>
-            <a:r>
-              <a:rPr sz="1200"/>
-              <a:t>, </a:t>
-            </a:r>
-            <a:r>
-              <a:rPr sz="1200"/>
-              <a:t>DEMO-2688</a:t>
-            </a:r>
-            <a:r>
-              <a:rPr sz="1200"/>
-              <a:t>, </a:t>
-            </a:r>
-            <a:r>
-              <a:rPr sz="1200"/>
-              <a:t>DEMO-2702</a:t>
-            </a:r>
-            <a:r>
-              <a:rPr sz="1200"/>
-              <a:t>, </a:t>
-            </a:r>
-            <a:r>
-              <a:rPr sz="1200"/>
-              <a:t>DEMO-2722</a:t>
-            </a:r>
-            <a:r>
-              <a:rPr sz="1200"/>
-              <a:t>, </a:t>
-            </a:r>
-            <a:r>
-              <a:rPr sz="1200"/>
-              <a:t>DEMO-2726</a:t>
-            </a:r>
-            <a:r>
-              <a:rPr sz="1200"/>
-              <a:t>, </a:t>
-            </a:r>
-            <a:r>
-              <a:rPr sz="1200"/>
-              <a:t>DEMO-2729</a:t>
-            </a:r>
-            <a:r>
-              <a:rPr sz="1200"/>
-              <a:t>, </a:t>
-            </a:r>
-            <a:r>
-              <a:rPr sz="1200"/>
-              <a:t>DEMO-2756</a:t>
-            </a:r>
-            <a:r>
-              <a:rPr sz="1200"/>
-              <a:t>, </a:t>
-            </a:r>
-            <a:r>
-              <a:rPr sz="1200"/>
-              <a:t>DEMO-2758</a:t>
-            </a:r>
-            <a:r>
-              <a:rPr sz="1200"/>
-              <a:t>, </a:t>
-            </a:r>
-            <a:r>
-              <a:rPr sz="1200"/>
-              <a:t>DEMO-2766</a:t>
-            </a:r>
-            <a:r>
-              <a:rPr sz="1200"/>
-              <a:t>, </a:t>
-            </a:r>
-            <a:r>
-              <a:rPr sz="1200"/>
-              <a:t>DEMO-2795</a:t>
-            </a:r>
-            <a:r>
-              <a:rPr sz="1200"/>
-              <a:t>, </a:t>
-            </a:r>
-            <a:r>
-              <a:rPr sz="1200"/>
-              <a:t>DEMO-2804</a:t>
-            </a:r>
-            <a:r>
-              <a:rPr sz="1200"/>
-              <a:t>, </a:t>
-            </a:r>
-            <a:r>
-              <a:rPr sz="1200"/>
-              <a:t>DEMO-2810</a:t>
-            </a:r>
-            <a:r>
-              <a:rPr sz="1200"/>
-              <a:t>, </a:t>
-            </a:r>
-            <a:r>
-              <a:rPr sz="1200"/>
-              <a:t>DEMO-2826</a:t>
-            </a:r>
-            <a:r>
-              <a:rPr sz="1200"/>
-              <a:t>, </a:t>
-            </a:r>
-            <a:r>
-              <a:rPr sz="1200"/>
-              <a:t>DEMO-2835</a:t>
-            </a:r>
-            <a:r>
-              <a:rPr sz="1200"/>
-              <a:t>, </a:t>
-            </a:r>
-            <a:r>
-              <a:rPr sz="1200"/>
-              <a:t>DEMO-2870</a:t>
-            </a:r>
-            <a:r>
-              <a:rPr sz="1200"/>
-              <a:t>, </a:t>
-            </a:r>
-            <a:r>
-              <a:rPr sz="1200"/>
-              <a:t>DEMO-2923</a:t>
-            </a:r>
-            <a:r>
-              <a:rPr sz="1200"/>
-              <a:t>, </a:t>
-            </a:r>
-            <a:r>
-              <a:rPr sz="1200"/>
-              <a:t>DEMO-2932</a:t>
-            </a:r>
-            <a:r>
-              <a:rPr sz="1200"/>
-              <a:t>, </a:t>
-            </a:r>
-            <a:r>
-              <a:rPr sz="1200"/>
-              <a:t>DEMO-2938</a:t>
-            </a:r>
-            <a:r>
-              <a:rPr sz="1200"/>
-              <a:t>, </a:t>
-            </a:r>
-            <a:r>
-              <a:rPr sz="1200"/>
-              <a:t>DEMO-2960</a:t>
-            </a:r>
-            <a:r>
-              <a:rPr sz="1200"/>
-              <a:t>, </a:t>
-            </a:r>
-            <a:r>
-              <a:rPr sz="1200"/>
-              <a:t>DEMO-2973</a:t>
-            </a:r>
-            <a:r>
-              <a:rPr sz="1200"/>
-              <a:t>, </a:t>
-            </a:r>
-            <a:r>
-              <a:rPr sz="1200"/>
-              <a:t>DEMO-2983</a:t>
-            </a:r>
-            <a:r>
-              <a:rPr sz="1200"/>
-              <a:t>, </a:t>
-            </a:r>
-            <a:r>
-              <a:rPr sz="1200"/>
-              <a:t>DEMO-2994</a:t>
-            </a:r>
-            <a:r>
-              <a:rPr sz="1200"/>
-              <a:t>, </a:t>
-            </a:r>
-            <a:r>
-              <a:rPr sz="1200"/>
-              <a:t>DEMO-3011</a:t>
-            </a:r>
-            <a:r>
-              <a:rPr sz="1200"/>
-              <a:t>, </a:t>
-            </a:r>
-            <a:r>
-              <a:rPr sz="1200"/>
-              <a:t>DEMO-3029</a:t>
-            </a:r>
-            <a:r>
-              <a:rPr sz="1200"/>
-              <a:t>, </a:t>
-            </a:r>
-            <a:r>
-              <a:rPr sz="1200"/>
-              <a:t>DEMO-3033</a:t>
-            </a:r>
-            <a:r>
-              <a:rPr sz="1200"/>
-              <a:t>, </a:t>
-            </a:r>
-            <a:r>
-              <a:rPr sz="1200"/>
-              <a:t>DEMO-3040</a:t>
-            </a:r>
-            <a:r>
-              <a:rPr sz="1200"/>
-              <a:t>, </a:t>
-            </a:r>
-            <a:r>
-              <a:rPr sz="1200"/>
-              <a:t>DEMO-3055</a:t>
-            </a:r>
-            <a:r>
-              <a:rPr sz="1200"/>
-              <a:t>, </a:t>
-            </a:r>
-            <a:r>
-              <a:rPr sz="1200"/>
-              <a:t>DEMO-3068</a:t>
-            </a:r>
-            <a:r>
-              <a:rPr sz="1200"/>
-              <a:t>, </a:t>
-            </a:r>
-            <a:r>
-              <a:rPr sz="1200"/>
-              <a:t>DEMO-3069</a:t>
-            </a:r>
-            <a:r>
-              <a:rPr sz="1200"/>
-              <a:t>, </a:t>
-            </a:r>
-            <a:r>
-              <a:rPr sz="1200"/>
-              <a:t>DEMO-3072</a:t>
-            </a:r>
-            <a:r>
-              <a:rPr sz="1200"/>
-              <a:t>, </a:t>
-            </a:r>
-            <a:r>
-              <a:rPr sz="1200"/>
-              <a:t>DEMO-3084</a:t>
-            </a:r>
-            <a:r>
-              <a:rPr sz="1200"/>
-              <a:t>, </a:t>
-            </a:r>
-            <a:r>
-              <a:rPr sz="1200"/>
-              <a:t>DEMO-3103</a:t>
-            </a:r>
-            <a:r>
-              <a:rPr sz="1200"/>
-              <a:t>, </a:t>
-            </a:r>
-            <a:r>
-              <a:rPr sz="1200"/>
-              <a:t>DEMO-3104</a:t>
-            </a:r>
-            <a:r>
-              <a:rPr sz="1200"/>
-              <a:t>, </a:t>
-            </a:r>
-            <a:r>
-              <a:rPr sz="1200"/>
-              <a:t>DEMO-3105</a:t>
-            </a:r>
-            <a:r>
-              <a:rPr sz="1200"/>
-              <a:t>, </a:t>
-            </a:r>
-            <a:r>
-              <a:rPr sz="1200"/>
-              <a:t>DEMO-3150</a:t>
-            </a:r>
-            <a:r>
-              <a:rPr sz="1200"/>
-              <a:t>, </a:t>
-            </a:r>
-            <a:r>
-              <a:rPr sz="1200"/>
-              <a:t>DEMO-3170</a:t>
-            </a:r>
-            <a:r>
-              <a:rPr sz="1200"/>
-              <a:t>, </a:t>
-            </a:r>
-            <a:r>
-              <a:rPr sz="1200"/>
-              <a:t>DEMO-3180</a:t>
-            </a:r>
-            <a:r>
-              <a:rPr sz="1200"/>
-              <a:t>, </a:t>
-            </a:r>
-            <a:r>
-              <a:rPr sz="1200"/>
-              <a:t>DEMO-3183</a:t>
-            </a:r>
-            <a:r>
-              <a:rPr sz="1200"/>
-              <a:t>, </a:t>
-            </a:r>
-            <a:r>
-              <a:rPr sz="1200"/>
-              <a:t>DEMO-3206</a:t>
-            </a:r>
-            <a:r>
-              <a:rPr sz="1200"/>
-              <a:t>, </a:t>
-            </a:r>
-            <a:r>
-              <a:rPr sz="1200"/>
-              <a:t>DEMO-3250</a:t>
-            </a:r>
-            <a:r>
-              <a:rPr sz="1200"/>
-              <a:t>, </a:t>
-            </a:r>
-            <a:r>
-              <a:rPr sz="1200"/>
-              <a:t>DEMO-3252</a:t>
-            </a:r>
-            <a:r>
-              <a:rPr sz="1200"/>
-              <a:t>, </a:t>
-            </a:r>
-            <a:r>
-              <a:rPr sz="1200"/>
-              <a:t>DEMO-3257</a:t>
-            </a:r>
-            <a:r>
-              <a:rPr sz="1200"/>
-              <a:t>, </a:t>
-            </a:r>
-            <a:r>
-              <a:rPr sz="1200"/>
-              <a:t>DEMO-3266</a:t>
-            </a:r>
-            <a:r>
-              <a:rPr sz="1200"/>
-              <a:t>, </a:t>
-            </a:r>
-            <a:r>
-              <a:rPr sz="1200"/>
-              <a:t>DEMO-3269</a:t>
-            </a:r>
-            <a:r>
-              <a:rPr sz="1200"/>
-              <a:t>, </a:t>
-            </a:r>
-            <a:r>
-              <a:rPr sz="1200"/>
-              <a:t>DEMO-3272</a:t>
-            </a:r>
-            <a:r>
-              <a:rPr sz="1200"/>
-              <a:t>, </a:t>
-            </a:r>
-            <a:r>
-              <a:rPr sz="1200"/>
-              <a:t>DEMO-3276</a:t>
-            </a:r>
-            <a:r>
-              <a:rPr sz="1200"/>
-              <a:t>, </a:t>
-            </a:r>
-            <a:r>
-              <a:rPr sz="1200"/>
-              <a:t>DEMO-3285</a:t>
-            </a:r>
-            <a:r>
-              <a:rPr sz="1200"/>
-              <a:t>, </a:t>
-            </a:r>
-            <a:r>
-              <a:rPr sz="1200"/>
-              <a:t>DEMO-3297</a:t>
-            </a:r>
-            <a:r>
-              <a:rPr sz="1200"/>
-              <a:t>, </a:t>
-            </a:r>
-            <a:r>
-              <a:rPr sz="1200"/>
-              <a:t>DEMO-3306</a:t>
-            </a:r>
-            <a:r>
-              <a:rPr sz="1200"/>
-              <a:t>, </a:t>
-            </a:r>
-            <a:r>
-              <a:rPr sz="1200"/>
-              <a:t>DEMO-3315</a:t>
-            </a:r>
-            <a:r>
-              <a:rPr sz="1200"/>
-              <a:t>, </a:t>
-            </a:r>
-            <a:r>
-              <a:rPr sz="1200"/>
-              <a:t>DEMO-3363</a:t>
-            </a:r>
-            <a:r>
-              <a:rPr sz="1200"/>
-              <a:t>, </a:t>
-            </a:r>
-            <a:r>
-              <a:rPr sz="1200"/>
-              <a:t>DEMO-3374</a:t>
-            </a:r>
-            <a:r>
-              <a:rPr sz="1200"/>
-              <a:t>, </a:t>
-            </a:r>
-            <a:r>
-              <a:rPr sz="1200"/>
-              <a:t>DEMO-1324</a:t>
+              <a:t>DEMO-3450</a:t>
             </a:r>
           </a:p>
         </p:txBody>
@@ -6936,7 +5216,7 @@
                     <a:p>
                       <a:r>
                         <a:rPr sz="900"/>
-                        <a:t>533</a:t>
+                        <a:t>509</a:t>
                       </a:r>
                     </a:p>
                   </a:txBody>
@@ -6964,7 +5244,7 @@
                     <a:p>
                       <a:r>
                         <a:rPr sz="900"/>
-                        <a:t>32</a:t>
+                        <a:t>9</a:t>
                       </a:r>
                     </a:p>
                   </a:txBody>
@@ -6992,7 +5272,7 @@
                     <a:p>
                       <a:r>
                         <a:rPr sz="900"/>
-                        <a:t>171</a:t>
+                        <a:t>6</a:t>
                       </a:r>
                     </a:p>
                   </a:txBody>
@@ -7020,7 +5300,7 @@
                     <a:p>
                       <a:r>
                         <a:rPr sz="900"/>
-                        <a:t>102</a:t>
+                        <a:t>109</a:t>
                       </a:r>
                     </a:p>
                   </a:txBody>
@@ -7048,7 +5328,7 @@
                     <a:p>
                       <a:r>
                         <a:rPr sz="900"/>
-                        <a:t>55</a:t>
+                        <a:t>65</a:t>
                       </a:r>
                     </a:p>
                   </a:txBody>
@@ -7076,7 +5356,7 @@
                     <a:p>
                       <a:r>
                         <a:rPr sz="900"/>
-                        <a:t>14</a:t>
+                        <a:t>13</a:t>
                       </a:r>
                     </a:p>
                   </a:txBody>
@@ -7160,7 +5440,7 @@
                     <a:p>
                       <a:r>
                         <a:rPr sz="900"/>
-                        <a:t>0 %</a:t>
+                        <a:t>100 %</a:t>
                       </a:r>
                     </a:p>
                   </a:txBody>
@@ -7264,7 +5544,7 @@
           <a:p>
             <a:r>
               <a:rPr sz="1200"/>
-              <a:t>Sortie du rouge non projetable (règle IND-2, IND-3, IND-5)</a:t>
+              <a:t>Pas de sortie du rouge projetée (probabilité 0 % sous 10 Jours ouvrés)</a:t>
             </a:r>
           </a:p>
         </p:txBody>
@@ -7338,7 +5618,7 @@
           <a:p>
             <a:r>
               <a:rPr sz="1200"/>
-              <a:t>IND-4 : 16,7 % (seuil ≥ 10 %)</a:t>
+              <a:t>IND-4 : 18 % (seuil ≥ 10 %)</a:t>
             </a:r>
           </a:p>
           <a:p>
@@ -7348,7 +5628,7 @@
             </a:r>
             <a:r>
               <a:rPr sz="1200"/>
-              <a:t>DEMO-2293</a:t>
+              <a:t>DEMO-2350</a:t>
             </a:r>
             <a:r>
               <a:rPr sz="1200"/>
@@ -7356,7 +5636,7 @@
             </a:r>
             <a:r>
               <a:rPr sz="1200"/>
-              <a:t>DEMO-2484</a:t>
+              <a:t>DEMO-2414</a:t>
             </a:r>
             <a:r>
               <a:rPr sz="1200"/>
@@ -7364,7 +5644,7 @@
             </a:r>
             <a:r>
               <a:rPr sz="1200"/>
-              <a:t>DEMO-2529</a:t>
+              <a:t>DEMO-2612</a:t>
             </a:r>
             <a:r>
               <a:rPr sz="1200"/>
@@ -7372,7 +5652,7 @@
             </a:r>
             <a:r>
               <a:rPr sz="1200"/>
-              <a:t>DEMO-2544</a:t>
+              <a:t>DEMO-2654</a:t>
             </a:r>
             <a:r>
               <a:rPr sz="1200"/>
@@ -7380,7 +5660,7 @@
             </a:r>
             <a:r>
               <a:rPr sz="1200"/>
-              <a:t>DEMO-2545</a:t>
+              <a:t>DEMO-2658</a:t>
             </a:r>
             <a:r>
               <a:rPr sz="1200"/>
@@ -7388,7 +5668,7 @@
             </a:r>
             <a:r>
               <a:rPr sz="1200"/>
-              <a:t>DEMO-2721</a:t>
+              <a:t>DEMO-2665</a:t>
             </a:r>
             <a:r>
               <a:rPr sz="1200"/>
@@ -7396,7 +5676,7 @@
             </a:r>
             <a:r>
               <a:rPr sz="1200"/>
-              <a:t>DEMO-2819</a:t>
+              <a:t>DEMO-2679</a:t>
             </a:r>
             <a:r>
               <a:rPr sz="1200"/>
@@ -7404,7 +5684,7 @@
             </a:r>
             <a:r>
               <a:rPr sz="1200"/>
-              <a:t>DEMO-2869</a:t>
+              <a:t>DEMO-2687</a:t>
             </a:r>
             <a:r>
               <a:rPr sz="1200"/>
@@ -7412,7 +5692,7 @@
             </a:r>
             <a:r>
               <a:rPr sz="1200"/>
-              <a:t>DEMO-2954</a:t>
+              <a:t>DEMO-2740</a:t>
             </a:r>
             <a:r>
               <a:rPr sz="1200"/>
@@ -7420,7 +5700,7 @@
             </a:r>
             <a:r>
               <a:rPr sz="1200"/>
-              <a:t>DEMO-2964</a:t>
+              <a:t>DEMO-2843</a:t>
             </a:r>
             <a:r>
               <a:rPr sz="1200"/>
@@ -7428,7 +5708,7 @@
             </a:r>
             <a:r>
               <a:rPr sz="1200"/>
-              <a:t>DEMO-2966</a:t>
+              <a:t>DEMO-2868</a:t>
             </a:r>
             <a:r>
               <a:rPr sz="1200"/>
@@ -7436,7 +5716,7 @@
             </a:r>
             <a:r>
               <a:rPr sz="1200"/>
-              <a:t>DEMO-3042</a:t>
+              <a:t>DEMO-2944</a:t>
             </a:r>
             <a:r>
               <a:rPr sz="1200"/>
@@ -7444,7 +5724,7 @@
             </a:r>
             <a:r>
               <a:rPr sz="1200"/>
-              <a:t>DEMO-3137</a:t>
+              <a:t>DEMO-3011</a:t>
             </a:r>
             <a:r>
               <a:rPr sz="1200"/>
@@ -7452,7 +5732,7 @@
             </a:r>
             <a:r>
               <a:rPr sz="1200"/>
-              <a:t>DEMO-3220</a:t>
+              <a:t>DEMO-3041</a:t>
             </a:r>
             <a:r>
               <a:rPr sz="1200"/>
@@ -7460,7 +5740,103 @@
             </a:r>
             <a:r>
               <a:rPr sz="1200"/>
-              <a:t>DEMO-3338</a:t>
+              <a:t>DEMO-3100</a:t>
+            </a:r>
+            <a:r>
+              <a:rPr sz="1200"/>
+              <a:t>, </a:t>
+            </a:r>
+            <a:r>
+              <a:rPr sz="1200"/>
+              <a:t>DEMO-3111</a:t>
+            </a:r>
+            <a:r>
+              <a:rPr sz="1200"/>
+              <a:t>, </a:t>
+            </a:r>
+            <a:r>
+              <a:rPr sz="1200"/>
+              <a:t>DEMO-3120</a:t>
+            </a:r>
+            <a:r>
+              <a:rPr sz="1200"/>
+              <a:t>, </a:t>
+            </a:r>
+            <a:r>
+              <a:rPr sz="1200"/>
+              <a:t>DEMO-3123</a:t>
+            </a:r>
+            <a:r>
+              <a:rPr sz="1200"/>
+              <a:t>, </a:t>
+            </a:r>
+            <a:r>
+              <a:rPr sz="1200"/>
+              <a:t>DEMO-3132</a:t>
+            </a:r>
+            <a:r>
+              <a:rPr sz="1200"/>
+              <a:t>, </a:t>
+            </a:r>
+            <a:r>
+              <a:rPr sz="1200"/>
+              <a:t>DEMO-3193</a:t>
+            </a:r>
+            <a:r>
+              <a:rPr sz="1200"/>
+              <a:t>, </a:t>
+            </a:r>
+            <a:r>
+              <a:rPr sz="1200"/>
+              <a:t>DEMO-3220</a:t>
+            </a:r>
+            <a:r>
+              <a:rPr sz="1200"/>
+              <a:t>, </a:t>
+            </a:r>
+            <a:r>
+              <a:rPr sz="1200"/>
+              <a:t>DEMO-3282</a:t>
+            </a:r>
+            <a:r>
+              <a:rPr sz="1200"/>
+              <a:t>, </a:t>
+            </a:r>
+            <a:r>
+              <a:rPr sz="1200"/>
+              <a:t>DEMO-3296</a:t>
+            </a:r>
+            <a:r>
+              <a:rPr sz="1200"/>
+              <a:t>, </a:t>
+            </a:r>
+            <a:r>
+              <a:rPr sz="1200"/>
+              <a:t>DEMO-3378</a:t>
+            </a:r>
+            <a:r>
+              <a:rPr sz="1200"/>
+              <a:t>, </a:t>
+            </a:r>
+            <a:r>
+              <a:rPr sz="1200"/>
+              <a:t>DEMO-3396</a:t>
+            </a:r>
+            <a:r>
+              <a:rPr sz="1200"/>
+              <a:t>, </a:t>
+            </a:r>
+            <a:r>
+              <a:rPr sz="1200"/>
+              <a:t>DEMO-3452</a:t>
+            </a:r>
+            <a:r>
+              <a:rPr sz="1200"/>
+              <a:t>, </a:t>
+            </a:r>
+            <a:r>
+              <a:rPr sz="1200"/>
+              <a:t>DEMO-3453</a:t>
             </a:r>
           </a:p>
         </p:txBody>
@@ -7536,7 +5912,7 @@
                     <a:p>
                       <a:r>
                         <a:rPr sz="900"/>
-                        <a:t>74</a:t>
+                        <a:t>70</a:t>
                       </a:r>
                     </a:p>
                   </a:txBody>
@@ -7620,7 +5996,7 @@
                     <a:p>
                       <a:r>
                         <a:rPr sz="900"/>
-                        <a:t>39</a:t>
+                        <a:t>36</a:t>
                       </a:r>
                     </a:p>
                   </a:txBody>
@@ -7648,7 +6024,7 @@
                     <a:p>
                       <a:r>
                         <a:rPr sz="900"/>
-                        <a:t>33</a:t>
+                        <a:t>38</a:t>
                       </a:r>
                     </a:p>
                   </a:txBody>
@@ -7732,7 +6108,7 @@
                     <a:p>
                       <a:r>
                         <a:rPr sz="900"/>
-                        <a:t>1,7 %</a:t>
+                        <a:t>3 %</a:t>
                       </a:r>
                     </a:p>
                   </a:txBody>
@@ -7760,7 +6136,7 @@
                     <a:p>
                       <a:r>
                         <a:rPr sz="900"/>
-                        <a:t>5,6 %</a:t>
+                        <a:t>6 %</a:t>
                       </a:r>
                     </a:p>
                   </a:txBody>
@@ -7788,7 +6164,7 @@
                     <a:p>
                       <a:r>
                         <a:rPr sz="900"/>
-                        <a:t>16,7 %</a:t>
+                        <a:t>18 %</a:t>
                       </a:r>
                     </a:p>
                   </a:txBody>
@@ -7864,7 +6240,7 @@
           <a:p>
             <a:r>
               <a:rPr sz="1200"/>
-              <a:t>Risque d'entrée en rouge IND-4 : franchissement estimé le 16/10/2026 (valeur 16,7 %, seuil rouge 20 %, horizon 5 Jours ouvrés)</a:t>
+              <a:t>Risque d'entrée en rouge IND-4 : franchissement estimé le 14/10/2026 (valeur 18 %, seuil rouge 20 %, horizon 5 Jours ouvrés), valeur projetée 20,7 %</a:t>
             </a:r>
           </a:p>
         </p:txBody>
@@ -8090,6 +6466,19 @@
                     <a:p>
                       <a:r>
                         <a:rPr sz="900"/>
+                        <a:t>6</a:t>
+                      </a:r>
+                    </a:p>
+                  </a:txBody>
+                  <a:tcPr/>
+                </a:tc>
+                <a:tc>
+                  <a:txBody>
+                    <a:bodyPr/>
+                    <a:lstStyle/>
+                    <a:p>
+                      <a:r>
+                        <a:rPr sz="900"/>
                         <a:t>4</a:t>
                       </a:r>
                     </a:p>
@@ -8103,72 +6492,59 @@
                     <a:p>
                       <a:r>
                         <a:rPr sz="900"/>
-                        <a:t>9</a:t>
-                      </a:r>
-                    </a:p>
-                  </a:txBody>
-                  <a:tcPr/>
-                </a:tc>
-                <a:tc>
-                  <a:txBody>
-                    <a:bodyPr/>
-                    <a:lstStyle/>
-                    <a:p>
-                      <a:r>
-                        <a:rPr sz="900"/>
-                        <a:t>17</a:t>
-                      </a:r>
-                    </a:p>
-                  </a:txBody>
-                  <a:tcPr/>
-                </a:tc>
-                <a:tc>
-                  <a:txBody>
-                    <a:bodyPr/>
-                    <a:lstStyle/>
-                    <a:p>
-                      <a:r>
-                        <a:rPr sz="900"/>
-                        <a:t>22</a:t>
-                      </a:r>
-                    </a:p>
-                  </a:txBody>
-                  <a:tcPr/>
-                </a:tc>
-                <a:tc>
-                  <a:txBody>
-                    <a:bodyPr/>
-                    <a:lstStyle/>
-                    <a:p>
-                      <a:r>
-                        <a:rPr sz="900"/>
-                        <a:t>52</a:t>
-                      </a:r>
-                    </a:p>
-                  </a:txBody>
-                  <a:tcPr/>
-                </a:tc>
-                <a:tc>
-                  <a:txBody>
-                    <a:bodyPr/>
-                    <a:lstStyle/>
-                    <a:p>
-                      <a:r>
-                        <a:rPr sz="900"/>
-                        <a:t>51</a:t>
-                      </a:r>
-                    </a:p>
-                  </a:txBody>
-                  <a:tcPr/>
-                </a:tc>
-                <a:tc>
-                  <a:txBody>
-                    <a:bodyPr/>
-                    <a:lstStyle/>
-                    <a:p>
-                      <a:r>
-                        <a:rPr sz="900"/>
-                        <a:t>53</a:t>
+                        <a:t>5</a:t>
+                      </a:r>
+                    </a:p>
+                  </a:txBody>
+                  <a:tcPr/>
+                </a:tc>
+                <a:tc>
+                  <a:txBody>
+                    <a:bodyPr/>
+                    <a:lstStyle/>
+                    <a:p>
+                      <a:r>
+                        <a:rPr sz="900"/>
+                        <a:t>6</a:t>
+                      </a:r>
+                    </a:p>
+                  </a:txBody>
+                  <a:tcPr/>
+                </a:tc>
+                <a:tc>
+                  <a:txBody>
+                    <a:bodyPr/>
+                    <a:lstStyle/>
+                    <a:p>
+                      <a:r>
+                        <a:rPr sz="900"/>
+                        <a:t>20</a:t>
+                      </a:r>
+                    </a:p>
+                  </a:txBody>
+                  <a:tcPr/>
+                </a:tc>
+                <a:tc>
+                  <a:txBody>
+                    <a:bodyPr/>
+                    <a:lstStyle/>
+                    <a:p>
+                      <a:r>
+                        <a:rPr sz="900"/>
+                        <a:t>13</a:t>
+                      </a:r>
+                    </a:p>
+                  </a:txBody>
+                  <a:tcPr/>
+                </a:tc>
+                <a:tc>
+                  <a:txBody>
+                    <a:bodyPr/>
+                    <a:lstStyle/>
+                    <a:p>
+                      <a:r>
+                        <a:rPr sz="900"/>
+                        <a:t>13</a:t>
                       </a:r>
                     </a:p>
                   </a:txBody>
@@ -8261,33 +6637,33 @@
                     <a:p>
                       <a:r>
                         <a:rPr sz="900"/>
-                        <a:t>26</a:t>
-                      </a:r>
-                    </a:p>
-                  </a:txBody>
-                  <a:tcPr/>
-                </a:tc>
-                <a:tc>
-                  <a:txBody>
-                    <a:bodyPr/>
-                    <a:lstStyle/>
-                    <a:p>
-                      <a:r>
-                        <a:rPr sz="900"/>
-                        <a:t>22</a:t>
-                      </a:r>
-                    </a:p>
-                  </a:txBody>
-                  <a:tcPr/>
-                </a:tc>
-                <a:tc>
-                  <a:txBody>
-                    <a:bodyPr/>
-                    <a:lstStyle/>
-                    <a:p>
-                      <a:r>
-                        <a:rPr sz="900"/>
-                        <a:t>21</a:t>
+                        <a:t>13</a:t>
+                      </a:r>
+                    </a:p>
+                  </a:txBody>
+                  <a:tcPr/>
+                </a:tc>
+                <a:tc>
+                  <a:txBody>
+                    <a:bodyPr/>
+                    <a:lstStyle/>
+                    <a:p>
+                      <a:r>
+                        <a:rPr sz="900"/>
+                        <a:t>5</a:t>
+                      </a:r>
+                    </a:p>
+                  </a:txBody>
+                  <a:tcPr/>
+                </a:tc>
+                <a:tc>
+                  <a:txBody>
+                    <a:bodyPr/>
+                    <a:lstStyle/>
+                    <a:p>
+                      <a:r>
+                        <a:rPr sz="900"/>
+                        <a:t>4</a:t>
                       </a:r>
                     </a:p>
                   </a:txBody>
@@ -8328,6 +6704,19 @@
                     <a:p>
                       <a:r>
                         <a:rPr sz="900"/>
+                        <a:t>6</a:t>
+                      </a:r>
+                    </a:p>
+                  </a:txBody>
+                  <a:tcPr/>
+                </a:tc>
+                <a:tc>
+                  <a:txBody>
+                    <a:bodyPr/>
+                    <a:lstStyle/>
+                    <a:p>
+                      <a:r>
+                        <a:rPr sz="900"/>
                         <a:t>4</a:t>
                       </a:r>
                     </a:p>
@@ -8341,72 +6730,59 @@
                     <a:p>
                       <a:r>
                         <a:rPr sz="900"/>
+                        <a:t>5</a:t>
+                      </a:r>
+                    </a:p>
+                  </a:txBody>
+                  <a:tcPr/>
+                </a:tc>
+                <a:tc>
+                  <a:txBody>
+                    <a:bodyPr/>
+                    <a:lstStyle/>
+                    <a:p>
+                      <a:r>
+                        <a:rPr sz="900"/>
+                        <a:t>6</a:t>
+                      </a:r>
+                    </a:p>
+                  </a:txBody>
+                  <a:tcPr/>
+                </a:tc>
+                <a:tc>
+                  <a:txBody>
+                    <a:bodyPr/>
+                    <a:lstStyle/>
+                    <a:p>
+                      <a:r>
+                        <a:rPr sz="900"/>
+                        <a:t>7</a:t>
+                      </a:r>
+                    </a:p>
+                  </a:txBody>
+                  <a:tcPr/>
+                </a:tc>
+                <a:tc>
+                  <a:txBody>
+                    <a:bodyPr/>
+                    <a:lstStyle/>
+                    <a:p>
+                      <a:r>
+                        <a:rPr sz="900"/>
+                        <a:t>8</a:t>
+                      </a:r>
+                    </a:p>
+                  </a:txBody>
+                  <a:tcPr/>
+                </a:tc>
+                <a:tc>
+                  <a:txBody>
+                    <a:bodyPr/>
+                    <a:lstStyle/>
+                    <a:p>
+                      <a:r>
+                        <a:rPr sz="900"/>
                         <a:t>9</a:t>
-                      </a:r>
-                    </a:p>
-                  </a:txBody>
-                  <a:tcPr/>
-                </a:tc>
-                <a:tc>
-                  <a:txBody>
-                    <a:bodyPr/>
-                    <a:lstStyle/>
-                    <a:p>
-                      <a:r>
-                        <a:rPr sz="900"/>
-                        <a:t>17</a:t>
-                      </a:r>
-                    </a:p>
-                  </a:txBody>
-                  <a:tcPr/>
-                </a:tc>
-                <a:tc>
-                  <a:txBody>
-                    <a:bodyPr/>
-                    <a:lstStyle/>
-                    <a:p>
-                      <a:r>
-                        <a:rPr sz="900"/>
-                        <a:t>22</a:t>
-                      </a:r>
-                    </a:p>
-                  </a:txBody>
-                  <a:tcPr/>
-                </a:tc>
-                <a:tc>
-                  <a:txBody>
-                    <a:bodyPr/>
-                    <a:lstStyle/>
-                    <a:p>
-                      <a:r>
-                        <a:rPr sz="900"/>
-                        <a:t>26</a:t>
-                      </a:r>
-                    </a:p>
-                  </a:txBody>
-                  <a:tcPr/>
-                </a:tc>
-                <a:tc>
-                  <a:txBody>
-                    <a:bodyPr/>
-                    <a:lstStyle/>
-                    <a:p>
-                      <a:r>
-                        <a:rPr sz="900"/>
-                        <a:t>29</a:t>
-                      </a:r>
-                    </a:p>
-                  </a:txBody>
-                  <a:tcPr/>
-                </a:tc>
-                <a:tc>
-                  <a:txBody>
-                    <a:bodyPr/>
-                    <a:lstStyle/>
-                    <a:p>
-                      <a:r>
-                        <a:rPr sz="900"/>
-                        <a:t>32</a:t>
                       </a:r>
                     </a:p>
                   </a:txBody>
@@ -9386,98 +7762,98 @@
                     <a:p>
                       <a:r>
                         <a:rPr sz="900"/>
-                        <a:t>0 %</a:t>
-                      </a:r>
-                    </a:p>
-                  </a:txBody>
-                  <a:tcPr/>
-                </a:tc>
-                <a:tc>
-                  <a:txBody>
-                    <a:bodyPr/>
-                    <a:lstStyle/>
-                    <a:p>
-                      <a:r>
-                        <a:rPr sz="900"/>
-                        <a:t>1,7 %</a:t>
-                      </a:r>
-                    </a:p>
-                  </a:txBody>
-                  <a:tcPr/>
-                </a:tc>
-                <a:tc>
-                  <a:txBody>
-                    <a:bodyPr/>
-                    <a:lstStyle/>
-                    <a:p>
-                      <a:r>
-                        <a:rPr sz="900"/>
-                        <a:t>1,6 %</a:t>
-                      </a:r>
-                    </a:p>
-                  </a:txBody>
-                  <a:tcPr/>
-                </a:tc>
-                <a:tc>
-                  <a:txBody>
-                    <a:bodyPr/>
-                    <a:lstStyle/>
-                    <a:p>
-                      <a:r>
-                        <a:rPr sz="900"/>
-                        <a:t>6,3 %</a:t>
-                      </a:r>
-                    </a:p>
-                  </a:txBody>
-                  <a:tcPr/>
-                </a:tc>
-                <a:tc>
-                  <a:txBody>
-                    <a:bodyPr/>
-                    <a:lstStyle/>
-                    <a:p>
-                      <a:r>
-                        <a:rPr sz="900"/>
-                        <a:t>6,3 %</a:t>
-                      </a:r>
-                    </a:p>
-                  </a:txBody>
-                  <a:tcPr/>
-                </a:tc>
-                <a:tc>
-                  <a:txBody>
-                    <a:bodyPr/>
-                    <a:lstStyle/>
-                    <a:p>
-                      <a:r>
-                        <a:rPr sz="900"/>
-                        <a:t>6,3 %</a:t>
-                      </a:r>
-                    </a:p>
-                  </a:txBody>
-                  <a:tcPr/>
-                </a:tc>
-                <a:tc>
-                  <a:txBody>
-                    <a:bodyPr/>
-                    <a:lstStyle/>
-                    <a:p>
-                      <a:r>
-                        <a:rPr sz="900"/>
-                        <a:t>6,3 %</a:t>
-                      </a:r>
-                    </a:p>
-                  </a:txBody>
-                  <a:tcPr/>
-                </a:tc>
-                <a:tc>
-                  <a:txBody>
-                    <a:bodyPr/>
-                    <a:lstStyle/>
-                    <a:p>
-                      <a:r>
-                        <a:rPr sz="900"/>
-                        <a:t>6,3 %</a:t>
+                        <a:t>2 %</a:t>
+                      </a:r>
+                    </a:p>
+                  </a:txBody>
+                  <a:tcPr/>
+                </a:tc>
+                <a:tc>
+                  <a:txBody>
+                    <a:bodyPr/>
+                    <a:lstStyle/>
+                    <a:p>
+                      <a:r>
+                        <a:rPr sz="900"/>
+                        <a:t>3 %</a:t>
+                      </a:r>
+                    </a:p>
+                  </a:txBody>
+                  <a:tcPr/>
+                </a:tc>
+                <a:tc>
+                  <a:txBody>
+                    <a:bodyPr/>
+                    <a:lstStyle/>
+                    <a:p>
+                      <a:r>
+                        <a:rPr sz="900"/>
+                        <a:t>3 %</a:t>
+                      </a:r>
+                    </a:p>
+                  </a:txBody>
+                  <a:tcPr/>
+                </a:tc>
+                <a:tc>
+                  <a:txBody>
+                    <a:bodyPr/>
+                    <a:lstStyle/>
+                    <a:p>
+                      <a:r>
+                        <a:rPr sz="900"/>
+                        <a:t>4 %</a:t>
+                      </a:r>
+                    </a:p>
+                  </a:txBody>
+                  <a:tcPr/>
+                </a:tc>
+                <a:tc>
+                  <a:txBody>
+                    <a:bodyPr/>
+                    <a:lstStyle/>
+                    <a:p>
+                      <a:r>
+                        <a:rPr sz="900"/>
+                        <a:t>4 %</a:t>
+                      </a:r>
+                    </a:p>
+                  </a:txBody>
+                  <a:tcPr/>
+                </a:tc>
+                <a:tc>
+                  <a:txBody>
+                    <a:bodyPr/>
+                    <a:lstStyle/>
+                    <a:p>
+                      <a:r>
+                        <a:rPr sz="900"/>
+                        <a:t>4,9 %</a:t>
+                      </a:r>
+                    </a:p>
+                  </a:txBody>
+                  <a:tcPr/>
+                </a:tc>
+                <a:tc>
+                  <a:txBody>
+                    <a:bodyPr/>
+                    <a:lstStyle/>
+                    <a:p>
+                      <a:r>
+                        <a:rPr sz="900"/>
+                        <a:t>4,9 %</a:t>
+                      </a:r>
+                    </a:p>
+                  </a:txBody>
+                  <a:tcPr/>
+                </a:tc>
+                <a:tc>
+                  <a:txBody>
+                    <a:bodyPr/>
+                    <a:lstStyle/>
+                    <a:p>
+                      <a:r>
+                        <a:rPr sz="900"/>
+                        <a:t>6,7 %</a:t>
                       </a:r>
                     </a:p>
                   </a:txBody>
@@ -9531,72 +7907,72 @@
                     <a:p>
                       <a:r>
                         <a:rPr sz="900"/>
-                        <a:t>0 %</a:t>
-                      </a:r>
-                    </a:p>
-                  </a:txBody>
-                  <a:tcPr/>
-                </a:tc>
-                <a:tc>
-                  <a:txBody>
-                    <a:bodyPr/>
-                    <a:lstStyle/>
-                    <a:p>
-                      <a:r>
-                        <a:rPr sz="900"/>
-                        <a:t>3,3 %</a:t>
-                      </a:r>
-                    </a:p>
-                  </a:txBody>
-                  <a:tcPr/>
-                </a:tc>
-                <a:tc>
-                  <a:txBody>
-                    <a:bodyPr/>
-                    <a:lstStyle/>
-                    <a:p>
-                      <a:r>
-                        <a:rPr sz="900"/>
-                        <a:t>5,5 %</a:t>
-                      </a:r>
-                    </a:p>
-                  </a:txBody>
-                  <a:tcPr/>
-                </a:tc>
-                <a:tc>
-                  <a:txBody>
-                    <a:bodyPr/>
-                    <a:lstStyle/>
-                    <a:p>
-                      <a:r>
-                        <a:rPr sz="900"/>
-                        <a:t>5,5 %</a:t>
-                      </a:r>
-                    </a:p>
-                  </a:txBody>
-                  <a:tcPr/>
-                </a:tc>
-                <a:tc>
-                  <a:txBody>
-                    <a:bodyPr/>
-                    <a:lstStyle/>
-                    <a:p>
-                      <a:r>
-                        <a:rPr sz="900"/>
-                        <a:t>5,4 %</a:t>
-                      </a:r>
-                    </a:p>
-                  </a:txBody>
-                  <a:tcPr/>
-                </a:tc>
-                <a:tc>
-                  <a:txBody>
-                    <a:bodyPr/>
-                    <a:lstStyle/>
-                    <a:p>
-                      <a:r>
-                        <a:rPr sz="900"/>
-                        <a:t>5,3 %</a:t>
+                        <a:t>2 %</a:t>
+                      </a:r>
+                    </a:p>
+                  </a:txBody>
+                  <a:tcPr/>
+                </a:tc>
+                <a:tc>
+                  <a:txBody>
+                    <a:bodyPr/>
+                    <a:lstStyle/>
+                    <a:p>
+                      <a:r>
+                        <a:rPr sz="900"/>
+                        <a:t>5 %</a:t>
+                      </a:r>
+                    </a:p>
+                  </a:txBody>
+                  <a:tcPr/>
+                </a:tc>
+                <a:tc>
+                  <a:txBody>
+                    <a:bodyPr/>
+                    <a:lstStyle/>
+                    <a:p>
+                      <a:r>
+                        <a:rPr sz="900"/>
+                        <a:t>6,6 %</a:t>
+                      </a:r>
+                    </a:p>
+                  </a:txBody>
+                  <a:tcPr/>
+                </a:tc>
+                <a:tc>
+                  <a:txBody>
+                    <a:bodyPr/>
+                    <a:lstStyle/>
+                    <a:p>
+                      <a:r>
+                        <a:rPr sz="900"/>
+                        <a:t>6,6 %</a:t>
+                      </a:r>
+                    </a:p>
+                  </a:txBody>
+                  <a:tcPr/>
+                </a:tc>
+                <a:tc>
+                  <a:txBody>
+                    <a:bodyPr/>
+                    <a:lstStyle/>
+                    <a:p>
+                      <a:r>
+                        <a:rPr sz="900"/>
+                        <a:t>7,1 %</a:t>
+                      </a:r>
+                    </a:p>
+                  </a:txBody>
+                  <a:tcPr/>
+                </a:tc>
+                <a:tc>
+                  <a:txBody>
+                    <a:bodyPr/>
+                    <a:lstStyle/>
+                    <a:p>
+                      <a:r>
+                        <a:rPr sz="900"/>
+                        <a:t>7,1 %</a:t>
                       </a:r>
                     </a:p>
                   </a:txBody>
@@ -9689,33 +8065,33 @@
                     <a:p>
                       <a:r>
                         <a:rPr sz="900"/>
-                        <a:t>6,7 %</a:t>
-                      </a:r>
-                    </a:p>
-                  </a:txBody>
-                  <a:tcPr/>
-                </a:tc>
-                <a:tc>
-                  <a:txBody>
-                    <a:bodyPr/>
-                    <a:lstStyle/>
-                    <a:p>
-                      <a:r>
-                        <a:rPr sz="900"/>
-                        <a:t>13,3 %</a:t>
-                      </a:r>
-                    </a:p>
-                  </a:txBody>
-                  <a:tcPr/>
-                </a:tc>
-                <a:tc>
-                  <a:txBody>
-                    <a:bodyPr/>
-                    <a:lstStyle/>
-                    <a:p>
-                      <a:r>
-                        <a:rPr sz="900"/>
-                        <a:t>16 %</a:t>
+                        <a:t>6 %</a:t>
+                      </a:r>
+                    </a:p>
+                  </a:txBody>
+                  <a:tcPr/>
+                </a:tc>
+                <a:tc>
+                  <a:txBody>
+                    <a:bodyPr/>
+                    <a:lstStyle/>
+                    <a:p>
+                      <a:r>
+                        <a:rPr sz="900"/>
+                        <a:t>13,9 %</a:t>
+                      </a:r>
+                    </a:p>
+                  </a:txBody>
+                  <a:tcPr/>
+                </a:tc>
+                <a:tc>
+                  <a:txBody>
+                    <a:bodyPr/>
+                    <a:lstStyle/>
+                    <a:p>
+                      <a:r>
+                        <a:rPr sz="900"/>
+                        <a:t>18,6 %</a:t>
                       </a:r>
                     </a:p>
                   </a:txBody>
@@ -9789,7 +8165,7 @@
           <a:p>
             <a:r>
               <a:rPr sz="1400"/>
-              <a:t>10 sur 53 bloquantes ouvertes</a:t>
+              <a:t>10 sur 13 bloquantes ouvertes</a:t>
             </a:r>
           </a:p>
         </p:txBody>
@@ -9908,7 +8284,7 @@
                     <a:p>
                       <a:r>
                         <a:rPr sz="1100"/>
-                        <a:t>DEMO-407</a:t>
+                        <a:t>DEMO-2842</a:t>
                       </a:r>
                     </a:p>
                   </a:txBody>
@@ -9934,7 +8310,167 @@
                     <a:p>
                       <a:r>
                         <a:rPr sz="1100"/>
-                        <a:t>Migration à blanc</a:t>
+                        <a:t>TNR</a:t>
+                      </a:r>
+                    </a:p>
+                  </a:txBody>
+                  <a:tcPr/>
+                </a:tc>
+                <a:tc>
+                  <a:txBody>
+                    <a:bodyPr/>
+                    <a:lstStyle/>
+                    <a:p>
+                      <a:r>
+                        <a:rPr sz="1100"/>
+                        <a:t>depots</a:t>
+                      </a:r>
+                    </a:p>
+                  </a:txBody>
+                  <a:tcPr/>
+                </a:tc>
+                <a:tc>
+                  <a:txBody>
+                    <a:bodyPr/>
+                    <a:lstStyle/>
+                    <a:p>
+                      <a:r>
+                        <a:rPr sz="1100"/>
+                        <a:t>À retester</a:t>
+                      </a:r>
+                    </a:p>
+                  </a:txBody>
+                  <a:tcPr/>
+                </a:tc>
+                <a:tc>
+                  <a:txBody>
+                    <a:bodyPr/>
+                    <a:lstStyle/>
+                    <a:p>
+                      <a:r>
+                        <a:rPr sz="1100"/>
+                        <a:t>7</a:t>
+                      </a:r>
+                    </a:p>
+                  </a:txBody>
+                  <a:tcPr/>
+                </a:tc>
+              </a:tr>
+              <a:tr h="330000">
+                <a:tc>
+                  <a:txBody>
+                    <a:bodyPr/>
+                    <a:lstStyle/>
+                    <a:p>
+                      <a:r>
+                        <a:rPr sz="1100"/>
+                        <a:t>DEMO-2928</a:t>
+                      </a:r>
+                    </a:p>
+                  </a:txBody>
+                  <a:tcPr/>
+                </a:tc>
+                <a:tc>
+                  <a:txBody>
+                    <a:bodyPr/>
+                    <a:lstStyle/>
+                    <a:p>
+                      <a:r>
+                        <a:rPr sz="1100"/>
+                        <a:t>ENT-B</a:t>
+                      </a:r>
+                    </a:p>
+                  </a:txBody>
+                  <a:tcPr/>
+                </a:tc>
+                <a:tc>
+                  <a:txBody>
+                    <a:bodyPr/>
+                    <a:lstStyle/>
+                    <a:p>
+                      <a:r>
+                        <a:rPr sz="1100"/>
+                        <a:t>TNR</a:t>
+                      </a:r>
+                    </a:p>
+                  </a:txBody>
+                  <a:tcPr/>
+                </a:tc>
+                <a:tc>
+                  <a:txBody>
+                    <a:bodyPr/>
+                    <a:lstStyle/>
+                    <a:p>
+                      <a:r>
+                        <a:rPr sz="1100"/>
+                        <a:t>depots</a:t>
+                      </a:r>
+                    </a:p>
+                  </a:txBody>
+                  <a:tcPr/>
+                </a:tc>
+                <a:tc>
+                  <a:txBody>
+                    <a:bodyPr/>
+                    <a:lstStyle/>
+                    <a:p>
+                      <a:r>
+                        <a:rPr sz="1100"/>
+                        <a:t>En correction</a:t>
+                      </a:r>
+                    </a:p>
+                  </a:txBody>
+                  <a:tcPr/>
+                </a:tc>
+                <a:tc>
+                  <a:txBody>
+                    <a:bodyPr/>
+                    <a:lstStyle/>
+                    <a:p>
+                      <a:r>
+                        <a:rPr sz="1100"/>
+                        <a:t>6</a:t>
+                      </a:r>
+                    </a:p>
+                  </a:txBody>
+                  <a:tcPr/>
+                </a:tc>
+              </a:tr>
+              <a:tr h="330000">
+                <a:tc>
+                  <a:txBody>
+                    <a:bodyPr/>
+                    <a:lstStyle/>
+                    <a:p>
+                      <a:r>
+                        <a:rPr sz="1100"/>
+                        <a:t>DEMO-3079</a:t>
+                      </a:r>
+                    </a:p>
+                  </a:txBody>
+                  <a:tcPr/>
+                </a:tc>
+                <a:tc>
+                  <a:txBody>
+                    <a:bodyPr/>
+                    <a:lstStyle/>
+                    <a:p>
+                      <a:r>
+                        <a:rPr sz="1100"/>
+                        <a:t>ENT-B</a:t>
+                      </a:r>
+                    </a:p>
+                  </a:txBody>
+                  <a:tcPr/>
+                </a:tc>
+                <a:tc>
+                  <a:txBody>
+                    <a:bodyPr/>
+                    <a:lstStyle/>
+                    <a:p>
+                      <a:r>
+                        <a:rPr sz="1100"/>
+                        <a:t>TNR</a:t>
                       </a:r>
                     </a:p>
                   </a:txBody>
@@ -9973,7 +8509,7 @@
                     <a:p>
                       <a:r>
                         <a:rPr sz="1100"/>
-                        <a:t>34</a:t>
+                        <a:t>5</a:t>
                       </a:r>
                     </a:p>
                   </a:txBody>
@@ -9988,7 +8524,87 @@
                     <a:p>
                       <a:r>
                         <a:rPr sz="1100"/>
-                        <a:t>DEMO-477</a:t>
+                        <a:t>DEMO-3117</a:t>
+                      </a:r>
+                    </a:p>
+                  </a:txBody>
+                  <a:tcPr/>
+                </a:tc>
+                <a:tc>
+                  <a:txBody>
+                    <a:bodyPr/>
+                    <a:lstStyle/>
+                    <a:p>
+                      <a:r>
+                        <a:rPr sz="1100"/>
+                        <a:t>ENT-A</a:t>
+                      </a:r>
+                    </a:p>
+                  </a:txBody>
+                  <a:tcPr/>
+                </a:tc>
+                <a:tc>
+                  <a:txBody>
+                    <a:bodyPr/>
+                    <a:lstStyle/>
+                    <a:p>
+                      <a:r>
+                        <a:rPr sz="1100"/>
+                        <a:t>TNR</a:t>
+                      </a:r>
+                    </a:p>
+                  </a:txBody>
+                  <a:tcPr/>
+                </a:tc>
+                <a:tc>
+                  <a:txBody>
+                    <a:bodyPr/>
+                    <a:lstStyle/>
+                    <a:p>
+                      <a:r>
+                        <a:rPr sz="1100"/>
+                        <a:t>comptabilite</a:t>
+                      </a:r>
+                    </a:p>
+                  </a:txBody>
+                  <a:tcPr/>
+                </a:tc>
+                <a:tc>
+                  <a:txBody>
+                    <a:bodyPr/>
+                    <a:lstStyle/>
+                    <a:p>
+                      <a:r>
+                        <a:rPr sz="1100"/>
+                        <a:t>En correction</a:t>
+                      </a:r>
+                    </a:p>
+                  </a:txBody>
+                  <a:tcPr/>
+                </a:tc>
+                <a:tc>
+                  <a:txBody>
+                    <a:bodyPr/>
+                    <a:lstStyle/>
+                    <a:p>
+                      <a:r>
+                        <a:rPr sz="1100"/>
+                        <a:t>4</a:t>
+                      </a:r>
+                    </a:p>
+                  </a:txBody>
+                  <a:tcPr/>
+                </a:tc>
+              </a:tr>
+              <a:tr h="330000">
+                <a:tc>
+                  <a:txBody>
+                    <a:bodyPr/>
+                    <a:lstStyle/>
+                    <a:p>
+                      <a:r>
+                        <a:rPr sz="1100"/>
+                        <a:t>DEMO-3128</a:t>
                       </a:r>
                     </a:p>
                   </a:txBody>
@@ -10014,7 +8630,247 @@
                     <a:p>
                       <a:r>
                         <a:rPr sz="1100"/>
-                        <a:t>Migration à blanc</a:t>
+                        <a:t>TNR</a:t>
+                      </a:r>
+                    </a:p>
+                  </a:txBody>
+                  <a:tcPr/>
+                </a:tc>
+                <a:tc>
+                  <a:txBody>
+                    <a:bodyPr/>
+                    <a:lstStyle/>
+                    <a:p>
+                      <a:r>
+                        <a:rPr sz="1100"/>
+                        <a:t>epargne</a:t>
+                      </a:r>
+                    </a:p>
+                  </a:txBody>
+                  <a:tcPr/>
+                </a:tc>
+                <a:tc>
+                  <a:txBody>
+                    <a:bodyPr/>
+                    <a:lstStyle/>
+                    <a:p>
+                      <a:r>
+                        <a:rPr sz="1100"/>
+                        <a:t>En correction</a:t>
+                      </a:r>
+                    </a:p>
+                  </a:txBody>
+                  <a:tcPr/>
+                </a:tc>
+                <a:tc>
+                  <a:txBody>
+                    <a:bodyPr/>
+                    <a:lstStyle/>
+                    <a:p>
+                      <a:r>
+                        <a:rPr sz="1100"/>
+                        <a:t>4</a:t>
+                      </a:r>
+                    </a:p>
+                  </a:txBody>
+                  <a:tcPr/>
+                </a:tc>
+              </a:tr>
+              <a:tr h="330000">
+                <a:tc>
+                  <a:txBody>
+                    <a:bodyPr/>
+                    <a:lstStyle/>
+                    <a:p>
+                      <a:r>
+                        <a:rPr sz="1100"/>
+                        <a:t>DEMO-3160</a:t>
+                      </a:r>
+                    </a:p>
+                  </a:txBody>
+                  <a:tcPr/>
+                </a:tc>
+                <a:tc>
+                  <a:txBody>
+                    <a:bodyPr/>
+                    <a:lstStyle/>
+                    <a:p>
+                      <a:r>
+                        <a:rPr sz="1100"/>
+                        <a:t>ENT-B</a:t>
+                      </a:r>
+                    </a:p>
+                  </a:txBody>
+                  <a:tcPr/>
+                </a:tc>
+                <a:tc>
+                  <a:txBody>
+                    <a:bodyPr/>
+                    <a:lstStyle/>
+                    <a:p>
+                      <a:r>
+                        <a:rPr sz="1100"/>
+                        <a:t>TNR</a:t>
+                      </a:r>
+                    </a:p>
+                  </a:txBody>
+                  <a:tcPr/>
+                </a:tc>
+                <a:tc>
+                  <a:txBody>
+                    <a:bodyPr/>
+                    <a:lstStyle/>
+                    <a:p>
+                      <a:r>
+                        <a:rPr sz="1100"/>
+                        <a:t>epargne</a:t>
+                      </a:r>
+                    </a:p>
+                  </a:txBody>
+                  <a:tcPr/>
+                </a:tc>
+                <a:tc>
+                  <a:txBody>
+                    <a:bodyPr/>
+                    <a:lstStyle/>
+                    <a:p>
+                      <a:r>
+                        <a:rPr sz="1100"/>
+                        <a:t>En correction</a:t>
+                      </a:r>
+                    </a:p>
+                  </a:txBody>
+                  <a:tcPr/>
+                </a:tc>
+                <a:tc>
+                  <a:txBody>
+                    <a:bodyPr/>
+                    <a:lstStyle/>
+                    <a:p>
+                      <a:r>
+                        <a:rPr sz="1100"/>
+                        <a:t>4</a:t>
+                      </a:r>
+                    </a:p>
+                  </a:txBody>
+                  <a:tcPr/>
+                </a:tc>
+              </a:tr>
+              <a:tr h="330000">
+                <a:tc>
+                  <a:txBody>
+                    <a:bodyPr/>
+                    <a:lstStyle/>
+                    <a:p>
+                      <a:r>
+                        <a:rPr sz="1100"/>
+                        <a:t>DEMO-3232</a:t>
+                      </a:r>
+                    </a:p>
+                  </a:txBody>
+                  <a:tcPr/>
+                </a:tc>
+                <a:tc>
+                  <a:txBody>
+                    <a:bodyPr/>
+                    <a:lstStyle/>
+                    <a:p>
+                      <a:r>
+                        <a:rPr sz="1100"/>
+                        <a:t>ENT-B</a:t>
+                      </a:r>
+                    </a:p>
+                  </a:txBody>
+                  <a:tcPr/>
+                </a:tc>
+                <a:tc>
+                  <a:txBody>
+                    <a:bodyPr/>
+                    <a:lstStyle/>
+                    <a:p>
+                      <a:r>
+                        <a:rPr sz="1100"/>
+                        <a:t>TNR</a:t>
+                      </a:r>
+                    </a:p>
+                  </a:txBody>
+                  <a:tcPr/>
+                </a:tc>
+                <a:tc>
+                  <a:txBody>
+                    <a:bodyPr/>
+                    <a:lstStyle/>
+                    <a:p>
+                      <a:r>
+                        <a:rPr sz="1100"/>
+                        <a:t>epargne</a:t>
+                      </a:r>
+                    </a:p>
+                  </a:txBody>
+                  <a:tcPr/>
+                </a:tc>
+                <a:tc>
+                  <a:txBody>
+                    <a:bodyPr/>
+                    <a:lstStyle/>
+                    <a:p>
+                      <a:r>
+                        <a:rPr sz="1100"/>
+                        <a:t>En correction</a:t>
+                      </a:r>
+                    </a:p>
+                  </a:txBody>
+                  <a:tcPr/>
+                </a:tc>
+                <a:tc>
+                  <a:txBody>
+                    <a:bodyPr/>
+                    <a:lstStyle/>
+                    <a:p>
+                      <a:r>
+                        <a:rPr sz="1100"/>
+                        <a:t>3</a:t>
+                      </a:r>
+                    </a:p>
+                  </a:txBody>
+                  <a:tcPr/>
+                </a:tc>
+              </a:tr>
+              <a:tr h="330000">
+                <a:tc>
+                  <a:txBody>
+                    <a:bodyPr/>
+                    <a:lstStyle/>
+                    <a:p>
+                      <a:r>
+                        <a:rPr sz="1100"/>
+                        <a:t>DEMO-3234</a:t>
+                      </a:r>
+                    </a:p>
+                  </a:txBody>
+                  <a:tcPr/>
+                </a:tc>
+                <a:tc>
+                  <a:txBody>
+                    <a:bodyPr/>
+                    <a:lstStyle/>
+                    <a:p>
+                      <a:r>
+                        <a:rPr sz="1100"/>
+                        <a:t>ENT-A</a:t>
+                      </a:r>
+                    </a:p>
+                  </a:txBody>
+                  <a:tcPr/>
+                </a:tc>
+                <a:tc>
+                  <a:txBody>
+                    <a:bodyPr/>
+                    <a:lstStyle/>
+                    <a:p>
+                      <a:r>
+                        <a:rPr sz="1100"/>
+                        <a:t>TNR</a:t>
                       </a:r>
                     </a:p>
                   </a:txBody>
@@ -10053,7 +8909,7 @@
                     <a:p>
                       <a:r>
                         <a:rPr sz="1100"/>
-                        <a:t>34</a:t>
+                        <a:t>3</a:t>
                       </a:r>
                     </a:p>
                   </a:txBody>
@@ -10068,7 +8924,7 @@
                     <a:p>
                       <a:r>
                         <a:rPr sz="1100"/>
-                        <a:t>DEMO-890</a:t>
+                        <a:t>DEMO-3307</a:t>
                       </a:r>
                     </a:p>
                   </a:txBody>
@@ -10094,7 +8950,7 @@
                     <a:p>
                       <a:r>
                         <a:rPr sz="1100"/>
-                        <a:t>Recette</a:t>
+                        <a:t>TNR</a:t>
                       </a:r>
                     </a:p>
                   </a:txBody>
@@ -10107,7 +8963,7 @@
                     <a:p>
                       <a:r>
                         <a:rPr sz="1100"/>
-                        <a:t>referentiel_clients</a:t>
+                        <a:t>credits</a:t>
                       </a:r>
                     </a:p>
                   </a:txBody>
@@ -10133,7 +8989,7 @@
                     <a:p>
                       <a:r>
                         <a:rPr sz="1100"/>
-                        <a:t>29</a:t>
+                        <a:t>2</a:t>
                       </a:r>
                     </a:p>
                   </a:txBody>
@@ -10148,7 +9004,7 @@
                     <a:p>
                       <a:r>
                         <a:rPr sz="1100"/>
-                        <a:t>DEMO-1023</a:t>
+                        <a:t>DEMO-3316</a:t>
                       </a:r>
                     </a:p>
                   </a:txBody>
@@ -10161,7 +9017,7 @@
                     <a:p>
                       <a:r>
                         <a:rPr sz="1100"/>
-                        <a:t>ENT-B</a:t>
+                        <a:t>ENT-A</a:t>
                       </a:r>
                     </a:p>
                   </a:txBody>
@@ -10174,7 +9030,7 @@
                     <a:p>
                       <a:r>
                         <a:rPr sz="1100"/>
-                        <a:t>Recette</a:t>
+                        <a:t>TNR</a:t>
                       </a:r>
                     </a:p>
                   </a:txBody>
@@ -10187,7 +9043,7 @@
                     <a:p>
                       <a:r>
                         <a:rPr sz="1100"/>
-                        <a:t>credits</a:t>
+                        <a:t>paiements</a:t>
                       </a:r>
                     </a:p>
                   </a:txBody>
@@ -10213,487 +9069,7 @@
                     <a:p>
                       <a:r>
                         <a:rPr sz="1100"/>
-                        <a:t>27</a:t>
-                      </a:r>
-                    </a:p>
-                  </a:txBody>
-                  <a:tcPr/>
-                </a:tc>
-              </a:tr>
-              <a:tr h="330000">
-                <a:tc>
-                  <a:txBody>
-                    <a:bodyPr/>
-                    <a:lstStyle/>
-                    <a:p>
-                      <a:r>
-                        <a:rPr sz="1100"/>
-                        <a:t>DEMO-1282</a:t>
-                      </a:r>
-                    </a:p>
-                  </a:txBody>
-                  <a:tcPr/>
-                </a:tc>
-                <a:tc>
-                  <a:txBody>
-                    <a:bodyPr/>
-                    <a:lstStyle/>
-                    <a:p>
-                      <a:r>
-                        <a:rPr sz="1100"/>
-                        <a:t>ENT-B</a:t>
-                      </a:r>
-                    </a:p>
-                  </a:txBody>
-                  <a:tcPr/>
-                </a:tc>
-                <a:tc>
-                  <a:txBody>
-                    <a:bodyPr/>
-                    <a:lstStyle/>
-                    <a:p>
-                      <a:r>
-                        <a:rPr sz="1100"/>
-                        <a:t>Recette</a:t>
-                      </a:r>
-                    </a:p>
-                  </a:txBody>
-                  <a:tcPr/>
-                </a:tc>
-                <a:tc>
-                  <a:txBody>
-                    <a:bodyPr/>
-                    <a:lstStyle/>
-                    <a:p>
-                      <a:r>
-                        <a:rPr sz="1100"/>
-                        <a:t>credits</a:t>
-                      </a:r>
-                    </a:p>
-                  </a:txBody>
-                  <a:tcPr/>
-                </a:tc>
-                <a:tc>
-                  <a:txBody>
-                    <a:bodyPr/>
-                    <a:lstStyle/>
-                    <a:p>
-                      <a:r>
-                        <a:rPr sz="1100"/>
-                        <a:t>En correction</a:t>
-                      </a:r>
-                    </a:p>
-                  </a:txBody>
-                  <a:tcPr/>
-                </a:tc>
-                <a:tc>
-                  <a:txBody>
-                    <a:bodyPr/>
-                    <a:lstStyle/>
-                    <a:p>
-                      <a:r>
-                        <a:rPr sz="1100"/>
-                        <a:t>24</a:t>
-                      </a:r>
-                    </a:p>
-                  </a:txBody>
-                  <a:tcPr/>
-                </a:tc>
-              </a:tr>
-              <a:tr h="330000">
-                <a:tc>
-                  <a:txBody>
-                    <a:bodyPr/>
-                    <a:lstStyle/>
-                    <a:p>
-                      <a:r>
-                        <a:rPr sz="1100"/>
-                        <a:t>DEMO-1305</a:t>
-                      </a:r>
-                    </a:p>
-                  </a:txBody>
-                  <a:tcPr/>
-                </a:tc>
-                <a:tc>
-                  <a:txBody>
-                    <a:bodyPr/>
-                    <a:lstStyle/>
-                    <a:p>
-                      <a:r>
-                        <a:rPr sz="1100"/>
-                        <a:t>ENT-B</a:t>
-                      </a:r>
-                    </a:p>
-                  </a:txBody>
-                  <a:tcPr/>
-                </a:tc>
-                <a:tc>
-                  <a:txBody>
-                    <a:bodyPr/>
-                    <a:lstStyle/>
-                    <a:p>
-                      <a:r>
-                        <a:rPr sz="1100"/>
-                        <a:t>Recette</a:t>
-                      </a:r>
-                    </a:p>
-                  </a:txBody>
-                  <a:tcPr/>
-                </a:tc>
-                <a:tc>
-                  <a:txBody>
-                    <a:bodyPr/>
-                    <a:lstStyle/>
-                    <a:p>
-                      <a:r>
-                        <a:rPr sz="1100"/>
-                        <a:t>credits</a:t>
-                      </a:r>
-                    </a:p>
-                  </a:txBody>
-                  <a:tcPr/>
-                </a:tc>
-                <a:tc>
-                  <a:txBody>
-                    <a:bodyPr/>
-                    <a:lstStyle/>
-                    <a:p>
-                      <a:r>
-                        <a:rPr sz="1100"/>
-                        <a:t>En correction</a:t>
-                      </a:r>
-                    </a:p>
-                  </a:txBody>
-                  <a:tcPr/>
-                </a:tc>
-                <a:tc>
-                  <a:txBody>
-                    <a:bodyPr/>
-                    <a:lstStyle/>
-                    <a:p>
-                      <a:r>
-                        <a:rPr sz="1100"/>
-                        <a:t>24</a:t>
-                      </a:r>
-                    </a:p>
-                  </a:txBody>
-                  <a:tcPr/>
-                </a:tc>
-              </a:tr>
-              <a:tr h="330000">
-                <a:tc>
-                  <a:txBody>
-                    <a:bodyPr/>
-                    <a:lstStyle/>
-                    <a:p>
-                      <a:r>
-                        <a:rPr sz="1100"/>
-                        <a:t>DEMO-1325</a:t>
-                      </a:r>
-                    </a:p>
-                  </a:txBody>
-                  <a:tcPr/>
-                </a:tc>
-                <a:tc>
-                  <a:txBody>
-                    <a:bodyPr/>
-                    <a:lstStyle/>
-                    <a:p>
-                      <a:r>
-                        <a:rPr sz="1100"/>
-                        <a:t>ENT-B</a:t>
-                      </a:r>
-                    </a:p>
-                  </a:txBody>
-                  <a:tcPr/>
-                </a:tc>
-                <a:tc>
-                  <a:txBody>
-                    <a:bodyPr/>
-                    <a:lstStyle/>
-                    <a:p>
-                      <a:r>
-                        <a:rPr sz="1100"/>
-                        <a:t>Recette</a:t>
-                      </a:r>
-                    </a:p>
-                  </a:txBody>
-                  <a:tcPr/>
-                </a:tc>
-                <a:tc>
-                  <a:txBody>
-                    <a:bodyPr/>
-                    <a:lstStyle/>
-                    <a:p>
-                      <a:r>
-                        <a:rPr sz="1100"/>
-                        <a:t>referentiel_clients</a:t>
-                      </a:r>
-                    </a:p>
-                  </a:txBody>
-                  <a:tcPr/>
-                </a:tc>
-                <a:tc>
-                  <a:txBody>
-                    <a:bodyPr/>
-                    <a:lstStyle/>
-                    <a:p>
-                      <a:r>
-                        <a:rPr sz="1100"/>
-                        <a:t>En correction</a:t>
-                      </a:r>
-                    </a:p>
-                  </a:txBody>
-                  <a:tcPr/>
-                </a:tc>
-                <a:tc>
-                  <a:txBody>
-                    <a:bodyPr/>
-                    <a:lstStyle/>
-                    <a:p>
-                      <a:r>
-                        <a:rPr sz="1100"/>
-                        <a:t>24</a:t>
-                      </a:r>
-                    </a:p>
-                  </a:txBody>
-                  <a:tcPr/>
-                </a:tc>
-              </a:tr>
-              <a:tr h="330000">
-                <a:tc>
-                  <a:txBody>
-                    <a:bodyPr/>
-                    <a:lstStyle/>
-                    <a:p>
-                      <a:r>
-                        <a:rPr sz="1100"/>
-                        <a:t>DEMO-1326</a:t>
-                      </a:r>
-                    </a:p>
-                  </a:txBody>
-                  <a:tcPr/>
-                </a:tc>
-                <a:tc>
-                  <a:txBody>
-                    <a:bodyPr/>
-                    <a:lstStyle/>
-                    <a:p>
-                      <a:r>
-                        <a:rPr sz="1100"/>
-                        <a:t>ENT-B</a:t>
-                      </a:r>
-                    </a:p>
-                  </a:txBody>
-                  <a:tcPr/>
-                </a:tc>
-                <a:tc>
-                  <a:txBody>
-                    <a:bodyPr/>
-                    <a:lstStyle/>
-                    <a:p>
-                      <a:r>
-                        <a:rPr sz="1100"/>
-                        <a:t>Recette</a:t>
-                      </a:r>
-                    </a:p>
-                  </a:txBody>
-                  <a:tcPr/>
-                </a:tc>
-                <a:tc>
-                  <a:txBody>
-                    <a:bodyPr/>
-                    <a:lstStyle/>
-                    <a:p>
-                      <a:r>
-                        <a:rPr sz="1100"/>
-                        <a:t>comptabilite</a:t>
-                      </a:r>
-                    </a:p>
-                  </a:txBody>
-                  <a:tcPr/>
-                </a:tc>
-                <a:tc>
-                  <a:txBody>
-                    <a:bodyPr/>
-                    <a:lstStyle/>
-                    <a:p>
-                      <a:r>
-                        <a:rPr sz="1100"/>
-                        <a:t>En correction</a:t>
-                      </a:r>
-                    </a:p>
-                  </a:txBody>
-                  <a:tcPr/>
-                </a:tc>
-                <a:tc>
-                  <a:txBody>
-                    <a:bodyPr/>
-                    <a:lstStyle/>
-                    <a:p>
-                      <a:r>
-                        <a:rPr sz="1100"/>
-                        <a:t>23</a:t>
-                      </a:r>
-                    </a:p>
-                  </a:txBody>
-                  <a:tcPr/>
-                </a:tc>
-              </a:tr>
-              <a:tr h="330000">
-                <a:tc>
-                  <a:txBody>
-                    <a:bodyPr/>
-                    <a:lstStyle/>
-                    <a:p>
-                      <a:r>
-                        <a:rPr sz="1100"/>
-                        <a:t>DEMO-1331</a:t>
-                      </a:r>
-                    </a:p>
-                  </a:txBody>
-                  <a:tcPr/>
-                </a:tc>
-                <a:tc>
-                  <a:txBody>
-                    <a:bodyPr/>
-                    <a:lstStyle/>
-                    <a:p>
-                      <a:r>
-                        <a:rPr sz="1100"/>
-                        <a:t>ENT-B</a:t>
-                      </a:r>
-                    </a:p>
-                  </a:txBody>
-                  <a:tcPr/>
-                </a:tc>
-                <a:tc>
-                  <a:txBody>
-                    <a:bodyPr/>
-                    <a:lstStyle/>
-                    <a:p>
-                      <a:r>
-                        <a:rPr sz="1100"/>
-                        <a:t>Recette</a:t>
-                      </a:r>
-                    </a:p>
-                  </a:txBody>
-                  <a:tcPr/>
-                </a:tc>
-                <a:tc>
-                  <a:txBody>
-                    <a:bodyPr/>
-                    <a:lstStyle/>
-                    <a:p>
-                      <a:r>
-                        <a:rPr sz="1100"/>
-                        <a:t>depots</a:t>
-                      </a:r>
-                    </a:p>
-                  </a:txBody>
-                  <a:tcPr/>
-                </a:tc>
-                <a:tc>
-                  <a:txBody>
-                    <a:bodyPr/>
-                    <a:lstStyle/>
-                    <a:p>
-                      <a:r>
-                        <a:rPr sz="1100"/>
-                        <a:t>En correction</a:t>
-                      </a:r>
-                    </a:p>
-                  </a:txBody>
-                  <a:tcPr/>
-                </a:tc>
-                <a:tc>
-                  <a:txBody>
-                    <a:bodyPr/>
-                    <a:lstStyle/>
-                    <a:p>
-                      <a:r>
-                        <a:rPr sz="1100"/>
-                        <a:t>23</a:t>
-                      </a:r>
-                    </a:p>
-                  </a:txBody>
-                  <a:tcPr/>
-                </a:tc>
-              </a:tr>
-              <a:tr h="330000">
-                <a:tc>
-                  <a:txBody>
-                    <a:bodyPr/>
-                    <a:lstStyle/>
-                    <a:p>
-                      <a:r>
-                        <a:rPr sz="1100"/>
-                        <a:t>DEMO-1349</a:t>
-                      </a:r>
-                    </a:p>
-                  </a:txBody>
-                  <a:tcPr/>
-                </a:tc>
-                <a:tc>
-                  <a:txBody>
-                    <a:bodyPr/>
-                    <a:lstStyle/>
-                    <a:p>
-                      <a:r>
-                        <a:rPr sz="1100"/>
-                        <a:t>ENT-B</a:t>
-                      </a:r>
-                    </a:p>
-                  </a:txBody>
-                  <a:tcPr/>
-                </a:tc>
-                <a:tc>
-                  <a:txBody>
-                    <a:bodyPr/>
-                    <a:lstStyle/>
-                    <a:p>
-                      <a:r>
-                        <a:rPr sz="1100"/>
-                        <a:t>Recette</a:t>
-                      </a:r>
-                    </a:p>
-                  </a:txBody>
-                  <a:tcPr/>
-                </a:tc>
-                <a:tc>
-                  <a:txBody>
-                    <a:bodyPr/>
-                    <a:lstStyle/>
-                    <a:p>
-                      <a:r>
-                        <a:rPr sz="1100"/>
-                        <a:t>paiements</a:t>
-                      </a:r>
-                    </a:p>
-                  </a:txBody>
-                  <a:tcPr/>
-                </a:tc>
-                <a:tc>
-                  <a:txBody>
-                    <a:bodyPr/>
-                    <a:lstStyle/>
-                    <a:p>
-                      <a:r>
-                        <a:rPr sz="1100"/>
-                        <a:t>En correction</a:t>
-                      </a:r>
-                    </a:p>
-                  </a:txBody>
-                  <a:tcPr/>
-                </a:tc>
-                <a:tc>
-                  <a:txBody>
-                    <a:bodyPr/>
-                    <a:lstStyle/>
-                    <a:p>
-                      <a:r>
-                        <a:rPr sz="1100"/>
-                        <a:t>23</a:t>
+                        <a:t>2</a:t>
                       </a:r>
                     </a:p>
                   </a:txBody>
@@ -11440,7 +9816,7 @@
                     <a:p>
                       <a:r>
                         <a:rPr sz="900"/>
-                        <a:t>3 384</a:t>
+                        <a:t>3 547</a:t>
                       </a:r>
                     </a:p>
                   </a:txBody>
@@ -11496,7 +9872,7 @@
                     <a:p>
                       <a:r>
                         <a:rPr sz="900"/>
-                        <a:t>8c0025b12291697467ff5bf4d24b52fc21674297378578e92cf7e58324c79035</a:t>
+                        <a:t>ccd712eb3c328843477dbc8ea0ea9a3becdbee5e7d5c04d8bafbf96550416a13</a:t>
                       </a:r>
                     </a:p>
                   </a:txBody>
@@ -11580,7 +9956,7 @@
                     <a:p>
                       <a:r>
                         <a:rPr sz="900"/>
-                        <a:t>1.1.0</a:t>
+                        <a:t>1.6.0</a:t>
                       </a:r>
                     </a:p>
                   </a:txBody>

</xml_diff>